<commit_message>
fixed the font name , font size and aligment of the overall domains and sub domains
</commit_message>
<xml_diff>
--- a/output.pptx
+++ b/output.pptx
@@ -22,6 +22,7 @@
     <p:sldId id="282" r:id="rId10"/>
     <p:sldId id="283" r:id="rId11"/>
     <p:sldId id="284" r:id="rId33"/>
+    <p:sldId id="285" r:id="rId34"/>
     <p:sldId id="262" r:id="rId12"/>
   </p:sldIdLst>
   <p:sldSz cx="7556500" cy="10693400"/>
@@ -3771,12 +3772,26 @@
           </a:bodyPr>
           <a:lstStyle/>
           <a:p>
-            <a:r>
+            <a:pPr algn="ctr"/>
+            <a:r>
+              <a:rPr sz="4400" b="1">
+                <a:solidFill>
+                  <a:srgbClr val="0070C0"/>
+                </a:solidFill>
+                <a:latin typeface="Calibri"/>
+              </a:rPr>
               <a:t>June</a:t>
             </a:r>
           </a:p>
           <a:p>
-            <a:r>
+            <a:pPr algn="ctr"/>
+            <a:r>
+              <a:rPr sz="4400" b="1">
+                <a:solidFill>
+                  <a:srgbClr val="0070C0"/>
+                </a:solidFill>
+                <a:latin typeface="Calibri"/>
+              </a:rPr>
               <a:t>2026-INSIGHTS</a:t>
             </a:r>
           </a:p>
@@ -3830,7 +3845,9 @@
         <p:txBody>
           <a:bodyPr/>
           <a:lstStyle/>
-          <a:p/>
+          <a:p>
+            <a:endParaRPr lang="en-US"/>
+          </a:p>
         </p:txBody>
       </p:sp>
       <p:grpSp>
@@ -4428,7 +4445,21 @@
           </a:bodyPr>
           <a:lstStyle/>
           <a:p>
-            <a:r>
+            <a:pPr algn="ctr">
+              <a:lnSpc>
+                <a:spcPts val="2362"/>
+              </a:lnSpc>
+            </a:pPr>
+            <a:r>
+              <a:rPr lang="en-US" sz="1920" spc="5" dirty="0">
+                <a:solidFill>
+                  <a:srgbClr val="FFFFFF"/>
+                </a:solidFill>
+                <a:latin typeface="Montserrat Classic"/>
+                <a:ea typeface="Montserrat Classic"/>
+                <a:cs typeface="Montserrat Classic"/>
+                <a:sym typeface="Montserrat Classic"/>
+              </a:rPr>
               <a:t>A Monthly newsletter from Akshayam  focusing on Listed Companies</a:t>
             </a:r>
           </a:p>
@@ -4455,17 +4486,123 @@
           </a:bodyPr>
           <a:lstStyle/>
           <a:p>
-            <a:r>
-              <a:t>Pravartiya is derived from Sanskrit term  "Pravritti" (activity or commencement), symbolizing the dissemination of crucial updates particularly in the domain of compliance and regulatory matters. The term suggests not only the initiation of action but also the ongoing flow of information and engagement with the necessary changes or updates.</a:t>
-            </a:r>
-          </a:p>
-          <a:p/>
-          <a:p>
-            <a:r>
+            <a:pPr algn="just">
+              <a:lnSpc>
+                <a:spcPts val="1400"/>
+              </a:lnSpc>
+              <a:spcBef>
+                <a:spcPct val="0"/>
+              </a:spcBef>
+            </a:pPr>
+            <a:r>
+              <a:rPr lang="en-US" sz="1000" b="1" i="1" dirty="0" err="1">
+                <a:solidFill>
+                  <a:srgbClr val="FFFFFF"/>
+                </a:solidFill>
+                <a:latin typeface="Canva Sans Bold Italics"/>
+                <a:ea typeface="Canva Sans Bold Italics"/>
+                <a:cs typeface="Canva Sans Bold Italics"/>
+                <a:sym typeface="Canva Sans Bold Italics"/>
+              </a:rPr>
+              <a:t>Pravartiya</a:t>
+            </a:r>
+            <a:r>
+              <a:rPr lang="en-US" sz="1000" b="1" i="1" dirty="0">
+                <a:solidFill>
+                  <a:srgbClr val="FFFFFF"/>
+                </a:solidFill>
+                <a:latin typeface="Canva Sans Bold Italics"/>
+                <a:ea typeface="Canva Sans Bold Italics"/>
+                <a:cs typeface="Canva Sans Bold Italics"/>
+                <a:sym typeface="Canva Sans Bold Italics"/>
+              </a:rPr>
+              <a:t> is derived from Sanskrit term  "</a:t>
+            </a:r>
+            <a:r>
+              <a:rPr lang="en-US" sz="1000" b="1" i="1" dirty="0" err="1">
+                <a:solidFill>
+                  <a:srgbClr val="FFFFFF"/>
+                </a:solidFill>
+                <a:latin typeface="Canva Sans Bold Italics"/>
+                <a:ea typeface="Canva Sans Bold Italics"/>
+                <a:cs typeface="Canva Sans Bold Italics"/>
+                <a:sym typeface="Canva Sans Bold Italics"/>
+              </a:rPr>
+              <a:t>Pravritti</a:t>
+            </a:r>
+            <a:r>
+              <a:rPr lang="en-US" sz="1000" b="1" i="1" dirty="0">
+                <a:solidFill>
+                  <a:srgbClr val="FFFFFF"/>
+                </a:solidFill>
+                <a:latin typeface="Canva Sans Bold Italics"/>
+                <a:ea typeface="Canva Sans Bold Italics"/>
+                <a:cs typeface="Canva Sans Bold Italics"/>
+                <a:sym typeface="Canva Sans Bold Italics"/>
+              </a:rPr>
+              <a:t>" (activity or commencement), symbolizing the dissemination of crucial updates particularly in the domain of compliance and regulatory matters. The term suggests not only the initiation of action but also the ongoing flow of information and engagement with the necessary changes or updates.</a:t>
+            </a:r>
+          </a:p>
+          <a:p>
+            <a:pPr algn="just">
+              <a:lnSpc>
+                <a:spcPts val="1400"/>
+              </a:lnSpc>
+              <a:spcBef>
+                <a:spcPct val="0"/>
+              </a:spcBef>
+            </a:pPr>
+            <a:endParaRPr lang="en-US" sz="1000" b="1" i="1" dirty="0">
+              <a:solidFill>
+                <a:srgbClr val="FFFFFF"/>
+              </a:solidFill>
+              <a:latin typeface="Canva Sans Bold Italics"/>
+              <a:ea typeface="Canva Sans Bold Italics"/>
+              <a:cs typeface="Canva Sans Bold Italics"/>
+              <a:sym typeface="Canva Sans Bold Italics"/>
+            </a:endParaRPr>
+          </a:p>
+          <a:p>
+            <a:pPr algn="just">
+              <a:lnSpc>
+                <a:spcPts val="1400"/>
+              </a:lnSpc>
+              <a:spcBef>
+                <a:spcPct val="0"/>
+              </a:spcBef>
+            </a:pPr>
+            <a:r>
+              <a:rPr lang="en-US" sz="1000" b="1" i="1" dirty="0">
+                <a:solidFill>
+                  <a:srgbClr val="FFFFFF"/>
+                </a:solidFill>
+                <a:latin typeface="Canva Sans Bold Italics"/>
+                <a:ea typeface="Canva Sans Bold Italics"/>
+                <a:cs typeface="Canva Sans Bold Italics"/>
+                <a:sym typeface="Canva Sans Bold Italics"/>
+              </a:rPr>
               <a:t>In this spirit, Akshayam presents this newsletter to aid listed entities with timely, actionable insights for navigating compliance with clarity. </a:t>
             </a:r>
           </a:p>
-          <a:p/>
+          <a:p>
+            <a:pPr algn="just">
+              <a:lnSpc>
+                <a:spcPts val="1400"/>
+              </a:lnSpc>
+              <a:spcBef>
+                <a:spcPct val="0"/>
+              </a:spcBef>
+            </a:pPr>
+            <a:endParaRPr lang="en-US" sz="1000" b="1" i="1" dirty="0">
+              <a:solidFill>
+                <a:srgbClr val="FFFFFF"/>
+              </a:solidFill>
+              <a:latin typeface="Canva Sans Bold Italics"/>
+              <a:ea typeface="Canva Sans Bold Italics"/>
+              <a:cs typeface="Canva Sans Bold Italics"/>
+              <a:sym typeface="Canva Sans Bold Italics"/>
+            </a:endParaRPr>
+          </a:p>
         </p:txBody>
       </p:sp>
       <p:pic>
@@ -4519,9 +4656,12 @@
           <a:bodyPr/>
           <a:lstStyle/>
           <a:p>
-            <a:r>
+            <a:fld id="{B6F15528-21DE-4FAA-801E-634DDDAF4B2B}" type="slidenum">
+              <a:rPr lang="en-US" smtClean="0"/>
+              <a:pPr/>
               <a:t>1</a:t>
-            </a:r>
+            </a:fld>
+            <a:endParaRPr lang="en-US"/>
           </a:p>
         </p:txBody>
       </p:sp>
@@ -4936,7 +5076,7 @@
                 <a:cs typeface="Montserrat Classic Bold"/>
                 <a:sym typeface="Montserrat Classic Bold"/>
               </a:rPr>
-              <a:t>Page 10 of 12</a:t>
+              <a:t>Page 10 of 13</a:t>
             </a:r>
           </a:p>
         </p:txBody>
@@ -5353,295 +5493,6 @@
         <p:spPr>
           <a:xfrm>
             <a:off x="457200" y="1828800"/>
-            <a:ext cx="6583680" cy="5358384"/>
-          </a:xfrm>
-          <a:prstGeom prst="rect">
-            <a:avLst/>
-          </a:prstGeom>
-          <a:noFill/>
-        </p:spPr>
-        <p:txBody>
-          <a:bodyPr wrap="square">
-            <a:spAutoFit/>
-          </a:bodyPr>
-          <a:lstStyle/>
-          <a:p>
-            <a:pPr>
-              <a:spcBef>
-                <a:spcPts val="0"/>
-              </a:spcBef>
-              <a:spcAft>
-                <a:spcPts val="200"/>
-              </a:spcAft>
-              <a:defRPr sz="1100"/>
-            </a:pPr>
-            <a:r>
-              <a:t>- Total number of employees</a:t>
-            </a:r>
-          </a:p>
-          <a:p>
-            <a:pPr>
-              <a:spcBef>
-                <a:spcPts val="0"/>
-              </a:spcBef>
-              <a:spcAft>
-                <a:spcPts val="200"/>
-              </a:spcAft>
-              <a:defRPr sz="1100"/>
-            </a:pPr>
-            <a:r>
-              <a:t>- Total remuneration (in INR crore)</a:t>
-            </a:r>
-          </a:p>
-          <a:p>
-            <a:pPr>
-              <a:spcBef>
-                <a:spcPts val="0"/>
-              </a:spcBef>
-              <a:spcAft>
-                <a:spcPts val="200"/>
-              </a:spcAft>
-              <a:defRPr sz="1100"/>
-            </a:pPr>
-            <a:r>
-              <a:t>- Chief Executive Officer (CEO), Chief Investment Officer (CIO), and Chief Operations Officer (COO) or their equivalent by whatever name called.</a:t>
-            </a:r>
-          </a:p>
-          <a:p>
-            <a:pPr>
-              <a:spcBef>
-                <a:spcPts val="1200"/>
-              </a:spcBef>
-              <a:spcAft>
-                <a:spcPts val="400"/>
-              </a:spcAft>
-              <a:defRPr sz="1100" b="1"/>
-            </a:pPr>
-            <a:r>
-              <a:t>2. Details of top ten employees in terms of remuneration for the period….:</a:t>
-            </a:r>
-          </a:p>
-          <a:p>
-            <a:pPr>
-              <a:spcBef>
-                <a:spcPts val="0"/>
-              </a:spcBef>
-              <a:spcAft>
-                <a:spcPts val="200"/>
-              </a:spcAft>
-              <a:defRPr sz="1100"/>
-            </a:pPr>
-            <a:r>
-              <a:t>- Particulars</a:t>
-            </a:r>
-          </a:p>
-          <a:p>
-            <a:pPr>
-              <a:spcBef>
-                <a:spcPts val="0"/>
-              </a:spcBef>
-              <a:spcAft>
-                <a:spcPts val="200"/>
-              </a:spcAft>
-              <a:defRPr sz="1100"/>
-            </a:pPr>
-            <a:r>
-              <a:t>- Total remuneration (in INR crore)</a:t>
-            </a:r>
-          </a:p>
-          <a:p>
-            <a:pPr>
-              <a:spcBef>
-                <a:spcPts val="0"/>
-              </a:spcBef>
-              <a:spcAft>
-                <a:spcPts val="200"/>
-              </a:spcAft>
-              <a:defRPr sz="1100"/>
-            </a:pPr>
-            <a:r>
-              <a:t>- Top ten employees in terms of remuneration drawn for that financial year</a:t>
-            </a:r>
-          </a:p>
-          <a:p>
-            <a:pPr>
-              <a:spcBef>
-                <a:spcPts val="400"/>
-              </a:spcBef>
-              <a:spcAft>
-                <a:spcPts val="600"/>
-              </a:spcAft>
-              <a:defRPr sz="1100"/>
-            </a:pPr>
-            <a:r>
-              <a:t>3. Annual Remuneration for the period…. for all employees whose annual remuneration is INR 1.02 crores or more OR monthly remuneration is INR 8.5 lakhs if employed for part of the year:</a:t>
-            </a:r>
-          </a:p>
-          <a:p>
-            <a:pPr>
-              <a:spcBef>
-                <a:spcPts val="0"/>
-              </a:spcBef>
-              <a:spcAft>
-                <a:spcPts val="200"/>
-              </a:spcAft>
-              <a:defRPr sz="1100"/>
-            </a:pPr>
-            <a:r>
-              <a:t>- Particulars</a:t>
-            </a:r>
-          </a:p>
-          <a:p>
-            <a:pPr>
-              <a:spcBef>
-                <a:spcPts val="0"/>
-              </a:spcBef>
-              <a:spcAft>
-                <a:spcPts val="200"/>
-              </a:spcAft>
-              <a:defRPr sz="1100"/>
-            </a:pPr>
-            <a:r>
-              <a:t>- Total number of employees</a:t>
-            </a:r>
-          </a:p>
-          <a:p>
-            <a:pPr>
-              <a:spcBef>
-                <a:spcPts val="0"/>
-              </a:spcBef>
-              <a:spcAft>
-                <a:spcPts val="200"/>
-              </a:spcAft>
-              <a:defRPr sz="1100"/>
-            </a:pPr>
-            <a:r>
-              <a:t>- Total remuneration (in INR crore)</a:t>
-            </a:r>
-          </a:p>
-          <a:p>
-            <a:pPr>
-              <a:spcBef>
-                <a:spcPts val="0"/>
-              </a:spcBef>
-              <a:spcAft>
-                <a:spcPts val="200"/>
-              </a:spcAft>
-              <a:defRPr sz="1100"/>
-            </a:pPr>
-            <a:r>
-              <a:t>- Employees whose annual remuneration was equal to or above INR 1.02 crore for the financial year or whose monthly remuneration in aggregate was not less than INR 8.5 lakhs per month, if the employee is employed for a part of that financial year.</a:t>
-            </a:r>
-          </a:p>
-          <a:p>
-            <a:pPr>
-              <a:spcBef>
-                <a:spcPts val="400"/>
-              </a:spcBef>
-              <a:spcAft>
-                <a:spcPts val="600"/>
-              </a:spcAft>
-              <a:defRPr sz="1100"/>
-            </a:pPr>
-            <a:r>
-              <a:t>4. The ratio of CEO’s remuneration to median remuneration of AMC employees (in the current format followed by AMCs).</a:t>
-            </a:r>
-          </a:p>
-          <a:p>
-            <a:pPr>
-              <a:spcBef>
-                <a:spcPts val="400"/>
-              </a:spcBef>
-              <a:spcAft>
-                <a:spcPts val="600"/>
-              </a:spcAft>
-              <a:defRPr sz="1100"/>
-            </a:pPr>
-            <a:r>
-              <a:t>5. MF’s total AAUM, debt AAUM and equity AAUM and rate of growth over last three years:</a:t>
-            </a:r>
-          </a:p>
-          <a:p>
-            <a:pPr>
-              <a:spcBef>
-                <a:spcPts val="0"/>
-              </a:spcBef>
-              <a:spcAft>
-                <a:spcPts val="200"/>
-              </a:spcAft>
-              <a:defRPr sz="1100"/>
-            </a:pPr>
-            <a:r>
-              <a:t>- Year</a:t>
-            </a:r>
-          </a:p>
-          <a:p>
-            <a:pPr>
-              <a:spcBef>
-                <a:spcPts val="0"/>
-              </a:spcBef>
-              <a:spcAft>
-                <a:spcPts val="200"/>
-              </a:spcAft>
-              <a:defRPr sz="1100"/>
-            </a:pPr>
-            <a:r>
-              <a:t>- Total AAUM</a:t>
-            </a:r>
-          </a:p>
-          <a:p>
-            <a:pPr>
-              <a:spcBef>
-                <a:spcPts val="0"/>
-              </a:spcBef>
-              <a:spcAft>
-                <a:spcPts val="200"/>
-              </a:spcAft>
-              <a:defRPr sz="1100"/>
-            </a:pPr>
-            <a:r>
-              <a:t>- % of Debt AAUM</a:t>
-            </a:r>
-          </a:p>
-          <a:p>
-            <a:pPr>
-              <a:spcBef>
-                <a:spcPts val="0"/>
-              </a:spcBef>
-              <a:spcAft>
-                <a:spcPts val="200"/>
-              </a:spcAft>
-              <a:defRPr sz="1100"/>
-            </a:pPr>
-            <a:r>
-              <a:t>- % of Equity AAUM</a:t>
-            </a:r>
-          </a:p>
-          <a:p>
-            <a:pPr>
-              <a:spcBef>
-                <a:spcPts val="0"/>
-              </a:spcBef>
-              <a:spcAft>
-                <a:spcPts val="200"/>
-              </a:spcAft>
-              <a:defRPr sz="1100"/>
-            </a:pPr>
-            <a:r>
-              <a:t>- % of growth (INR in crore over the previous year)</a:t>
-            </a:r>
-          </a:p>
-        </p:txBody>
-      </p:sp>
-      <p:sp>
-        <p:nvSpPr>
-          <p:cNvPr id="17" name="TextBox 16"/>
-          <p:cNvSpPr txBox="1"/>
-          <p:nvPr/>
-        </p:nvSpPr>
-        <p:spPr>
-          <a:xfrm>
-            <a:off x="457200" y="7324344"/>
             <a:ext cx="6583680" cy="457200"/>
           </a:xfrm>
           <a:prstGeom prst="rect">
@@ -5670,14 +5521,14 @@
       </p:sp>
       <p:sp>
         <p:nvSpPr>
-          <p:cNvPr id="18" name="TextBox 17"/>
+          <p:cNvPr id="17" name="TextBox 16"/>
           <p:cNvSpPr txBox="1"/>
           <p:nvPr/>
         </p:nvSpPr>
         <p:spPr>
           <a:xfrm>
-            <a:off x="457200" y="7781544"/>
-            <a:ext cx="6583680" cy="1353311"/>
+            <a:off x="457200" y="2286000"/>
+            <a:ext cx="6583680" cy="5431536"/>
           </a:xfrm>
           <a:prstGeom prst="rect">
             <a:avLst/>
@@ -5717,6 +5568,76 @@
             </a:pPr>
             <a:r>
               <a:t>Background:</a:t>
+            </a:r>
+          </a:p>
+          <a:p>
+            <a:pPr>
+              <a:spcBef>
+                <a:spcPts val="400"/>
+              </a:spcBef>
+              <a:spcAft>
+                <a:spcPts val="600"/>
+              </a:spcAft>
+              <a:defRPr sz="1100"/>
+            </a:pPr>
+            <a:r>
+              <a:t>Maithan Alloys Limited is a company engaged in manufacturing ferro alloys and real estate business activities. The promoter of the company is Mr. Subhas Chandra Agarwalla, who is also the Chairman and Managing Director of the company. Several family members are employees of the company and receive remuneration. One of these family members, Mr. Siddhartha Shankar Agarwalla, is a cousin of Mr. Subhas Chandra Agarwalla and is proposed to become an Independent Director on the Board of Directors of Maithan Alloys Limited.</a:t>
+            </a:r>
+          </a:p>
+          <a:p>
+            <a:pPr>
+              <a:spcBef>
+                <a:spcPts val="1200"/>
+              </a:spcBef>
+              <a:spcAft>
+                <a:spcPts val="400"/>
+              </a:spcAft>
+              <a:defRPr sz="1100" b="1"/>
+            </a:pPr>
+            <a:r>
+              <a:t>Query:</a:t>
+            </a:r>
+          </a:p>
+          <a:p>
+            <a:pPr>
+              <a:spcBef>
+                <a:spcPts val="400"/>
+              </a:spcBef>
+              <a:spcAft>
+                <a:spcPts val="600"/>
+              </a:spcAft>
+              <a:defRPr sz="1100"/>
+            </a:pPr>
+            <a:r>
+              <a:t>Does the cousin of a director/promoter qualify as a person related to such director/promoter in terms of Regulation 16(1)(b)(iii) of the LODR (Listing Obligations and Disclosure Requirements) Regulations?</a:t>
+            </a:r>
+          </a:p>
+          <a:p>
+            <a:pPr>
+              <a:spcBef>
+                <a:spcPts val="1200"/>
+              </a:spcBef>
+              <a:spcAft>
+                <a:spcPts val="400"/>
+              </a:spcAft>
+              <a:defRPr sz="1100" b="1"/>
+            </a:pPr>
+            <a:r>
+              <a:t>Response:</a:t>
+            </a:r>
+          </a:p>
+          <a:p>
+            <a:pPr>
+              <a:spcBef>
+                <a:spcPts val="400"/>
+              </a:spcBef>
+              <a:spcAft>
+                <a:spcPts val="600"/>
+              </a:spcAft>
+              <a:defRPr sz="1100"/>
+            </a:pPr>
+            <a:r>
+              <a:t>The cousin of Mr. Siddhartha Shankar Agarwalla, who is proposed to become an Independent Director, is not identified as a relative under the definition of the term 'relative' in terms of Rule 4 of the Companies (Specification of definitions details) Rules, 2014 read with Section 2(77) of the Companies Act, 2013 and Regulation 2(1)(zd) of the LODR Regulations. Therefore, the cousin may be eligible to be appointed as an 'Independent Director' of the company. However, other criteria for the appointment of a person as an Independent Director should also be met, including holding securities or interest in the listed entity as specified in regulation 16(1)(b)(iv) of the LODR Regulations. The final decision on the question presented would depend on different facts and conditions.</a:t>
             </a:r>
           </a:p>
         </p:txBody>
@@ -7154,7 +7075,7 @@
                 <a:cs typeface="Montserrat Classic Bold"/>
                 <a:sym typeface="Montserrat Classic Bold"/>
               </a:rPr>
-              <a:t>Page 11 of 12</a:t>
+              <a:t>Page 11 of 13</a:t>
             </a:r>
           </a:p>
         </p:txBody>
@@ -7565,7 +7486,7 @@
         <p:spPr>
           <a:xfrm>
             <a:off x="457200" y="1828800"/>
-            <a:ext cx="6583680" cy="4078224"/>
+            <a:ext cx="6583680" cy="457200"/>
           </a:xfrm>
           <a:prstGeom prst="rect">
             <a:avLst/>
@@ -7573,14 +7494,79 @@
           <a:noFill/>
         </p:spPr>
         <p:txBody>
+          <a:bodyPr wrap="none">
+            <a:spAutoFit/>
+          </a:bodyPr>
+          <a:lstStyle/>
+          <a:p>
+            <a:pPr>
+              <a:defRPr b="1" sz="1600">
+                <a:solidFill>
+                  <a:srgbClr val="003399"/>
+                </a:solidFill>
+              </a:defRPr>
+            </a:pPr>
+            <a:r>
+              <a:t>➤ CIRCULAR-BSE</a:t>
+            </a:r>
+          </a:p>
+        </p:txBody>
+      </p:sp>
+      <p:sp>
+        <p:nvSpPr>
+          <p:cNvPr id="18" name="TextBox 17"/>
+          <p:cNvSpPr txBox="1"/>
+          <p:nvPr/>
+        </p:nvSpPr>
+        <p:spPr>
+          <a:xfrm>
+            <a:off x="457200" y="2286000"/>
+            <a:ext cx="6583680" cy="5239512"/>
+          </a:xfrm>
+          <a:prstGeom prst="rect">
+            <a:avLst/>
+          </a:prstGeom>
+          <a:noFill/>
+        </p:spPr>
+        <p:txBody>
           <a:bodyPr wrap="square">
             <a:spAutoFit/>
           </a:bodyPr>
           <a:lstStyle/>
           <a:p>
             <a:pPr>
-              <a:spcBef>
+              <a:spcAft>
+                <a:spcPts val="600"/>
+              </a:spcAft>
+            </a:pPr>
+            <a:r>
+              <a:rPr b="1" sz="1200" u="sng">
+                <a:solidFill>
+                  <a:srgbClr val="0066CC"/>
+                </a:solidFill>
+                <a:hlinkClick r:id="rId3"/>
+              </a:rPr>
+              <a:t>Pre-Packaged Insolvency Resolution Process under Section 54L of the Insolvency and Bankruptcy Code, 2016</a:t>
+            </a:r>
+          </a:p>
+          <a:p>
+            <a:pPr>
+              <a:spcBef>
+                <a:spcPts val="1200"/>
+              </a:spcBef>
+              <a:spcAft>
                 <a:spcPts val="400"/>
+              </a:spcAft>
+              <a:defRPr sz="1100" b="1"/>
+            </a:pPr>
+            <a:r>
+              <a:t>Date of Circular:</a:t>
+            </a:r>
+          </a:p>
+          <a:p>
+            <a:pPr>
+              <a:spcBef>
+                <a:spcPts val="400"/>
               </a:spcBef>
               <a:spcAft>
                 <a:spcPts val="600"/>
@@ -7588,7 +7574,7 @@
               <a:defRPr sz="1100"/>
             </a:pPr>
             <a:r>
-              <a:t>Maithan Alloys Limited is a company engaged in manufacturing ferro alloys and real estate business activities. The promoter of the company is Mr. Subhas Chandra Agarwalla, who is also the Chairman and Managing Director of the company. Several family members are employees of the company and receive remuneration. One of these family members, Mr. Siddhartha Shankar Agarwalla, is a cousin of Mr. Subhas Chandra Agarwalla and is proposed to become an Independent Director on the Board of Directors of Maithan Alloys Limited.</a:t>
+              <a:t>2026-06-01</a:t>
             </a:r>
           </a:p>
           <a:p>
@@ -7602,7 +7588,7 @@
               <a:defRPr sz="1100" b="1"/>
             </a:pPr>
             <a:r>
-              <a:t>Query:</a:t>
+              <a:t>Effective Date:</a:t>
             </a:r>
           </a:p>
           <a:p>
@@ -7616,7 +7602,7 @@
               <a:defRPr sz="1100"/>
             </a:pPr>
             <a:r>
-              <a:t>Does the cousin of a director/promoter qualify as a person related to such director/promoter in terms of Regulation 16(1)(b)(iii) of the LODR (Listing Obligations and Disclosure Requirements) Regulations?</a:t>
+              <a:t>Not specified</a:t>
             </a:r>
           </a:p>
           <a:p>
@@ -7630,7 +7616,7 @@
               <a:defRPr sz="1100" b="1"/>
             </a:pPr>
             <a:r>
-              <a:t>Response:</a:t>
+              <a:t>Gist of amendment:</a:t>
             </a:r>
           </a:p>
           <a:p>
@@ -7644,7 +7630,1135 @@
               <a:defRPr sz="1100"/>
             </a:pPr>
             <a:r>
-              <a:t>The cousin of Mr. Siddhartha Shankar Agarwalla, who is proposed to become an Independent Director, is not identified as a relative under the definition of the term 'relative' in terms of Rule 4 of the Companies (Specification of definitions details) Rules, 2014 read with Section 2(77) of the Companies Act, 2013 and Regulation 2(1)(zd) of the LODR Regulations. Therefore, the cousin may be eligible to be appointed as an 'Independent Director' of the company. However, other criteria for the appointment of a person as an Independent Director should also be met, including holding securities or interest in the listed entity as specified in regulation 16(1)(b)(iv) of the LODR Regulations. The final decision on the question presented would depend on different facts and conditions.</a:t>
+              <a:t>BSE has issued this circular and Issued a circular introducing and modifying the application of SEBI regulations for Resolution Plans approved under Section 54L of the Insolvency and Bankruptcy Code, 2016 in Pre-Packaged Insolvency Resolution Process (PPIRP).</a:t>
+            </a:r>
+          </a:p>
+          <a:p>
+            <a:pPr>
+              <a:spcBef>
+                <a:spcPts val="1200"/>
+              </a:spcBef>
+              <a:spcAft>
+                <a:spcPts val="400"/>
+              </a:spcAft>
+              <a:defRPr sz="1100" b="1"/>
+            </a:pPr>
+            <a:r>
+              <a:t>Submission of disclosures:</a:t>
+            </a:r>
+          </a:p>
+          <a:p>
+            <a:pPr>
+              <a:spcBef>
+                <a:spcPts val="400"/>
+              </a:spcBef>
+              <a:spcAft>
+                <a:spcPts val="600"/>
+              </a:spcAft>
+              <a:defRPr sz="1100"/>
+            </a:pPr>
+            <a:r>
+              <a:t>Listing Centre - Listing Compliance department at BSE Limited</a:t>
+            </a:r>
+          </a:p>
+          <a:p>
+            <a:pPr>
+              <a:spcBef>
+                <a:spcPts val="400"/>
+              </a:spcBef>
+              <a:spcAft>
+                <a:spcPts val="600"/>
+              </a:spcAft>
+              <a:defRPr sz="1100"/>
+            </a:pPr>
+            <a:r>
+              <a:t>Resolution Plans approved under Section 54L of the IBC under PPIRP framework will not be eligible for exemptions available under various SEBI Regulations.</a:t>
+            </a:r>
+          </a:p>
+          <a:p>
+            <a:pPr>
+              <a:spcBef>
+                <a:spcPts val="0"/>
+              </a:spcBef>
+              <a:spcAft>
+                <a:spcPts val="200"/>
+              </a:spcAft>
+              <a:defRPr sz="1100"/>
+            </a:pPr>
+            <a:r>
+              <a:t>- Listed entities undergoing PPIRP shall comply with all applicable procedural and regulatory requirements prescribed under relevant SEBI Regulations.</a:t>
+            </a:r>
+          </a:p>
+          <a:p>
+            <a:pPr>
+              <a:spcBef>
+                <a:spcPts val="0"/>
+              </a:spcBef>
+              <a:spcAft>
+                <a:spcPts val="200"/>
+              </a:spcAft>
+              <a:defRPr sz="1100"/>
+            </a:pPr>
+            <a:r>
+              <a:t>- Submissions should be made to the Listing Compliance department at BSE Limited.</a:t>
+            </a:r>
+          </a:p>
+          <a:p>
+            <a:pPr>
+              <a:spcBef>
+                <a:spcPts val="0"/>
+              </a:spcBef>
+              <a:spcAft>
+                <a:spcPts val="200"/>
+              </a:spcAft>
+              <a:defRPr sz="1100"/>
+            </a:pPr>
+            <a:r>
+              <a:t>- No alternative submission routes are specified, please contact the Listing Compliance department for unlisted fiduciaries or alternative paths.</a:t>
+            </a:r>
+          </a:p>
+          <a:p>
+            <a:pPr>
+              <a:spcBef>
+                <a:spcPts val="0"/>
+              </a:spcBef>
+              <a:spcAft>
+                <a:spcPts val="200"/>
+              </a:spcAft>
+              <a:defRPr sz="1100"/>
+            </a:pPr>
+            <a:r>
+              <a:t>- Previous exemptions for Resolution Plans approved under Section 31 of the IBC no longer apply to PPIRP.</a:t>
+            </a:r>
+          </a:p>
+        </p:txBody>
+      </p:sp>
+      <p:sp>
+        <p:nvSpPr>
+          <p:cNvPr id="19" name="TextBox 18"/>
+          <p:cNvSpPr txBox="1"/>
+          <p:nvPr/>
+        </p:nvSpPr>
+        <p:spPr>
+          <a:xfrm>
+            <a:off x="457200" y="7662672"/>
+            <a:ext cx="6583680" cy="1801368"/>
+          </a:xfrm>
+          <a:prstGeom prst="rect">
+            <a:avLst/>
+          </a:prstGeom>
+          <a:noFill/>
+        </p:spPr>
+        <p:txBody>
+          <a:bodyPr wrap="square">
+            <a:spAutoFit/>
+          </a:bodyPr>
+          <a:lstStyle/>
+          <a:p>
+            <a:pPr>
+              <a:spcAft>
+                <a:spcPts val="600"/>
+              </a:spcAft>
+            </a:pPr>
+            <a:r>
+              <a:rPr b="1" sz="1200" u="sng">
+                <a:solidFill>
+                  <a:srgbClr val="0066CC"/>
+                </a:solidFill>
+                <a:hlinkClick r:id="rId4"/>
+              </a:rPr>
+              <a:t>Frequently Asked Questions (FAQs) on the submission of the Quarterly Integrated Filing – Governance</a:t>
+            </a:r>
+          </a:p>
+          <a:p>
+            <a:pPr>
+              <a:spcBef>
+                <a:spcPts val="1200"/>
+              </a:spcBef>
+              <a:spcAft>
+                <a:spcPts val="400"/>
+              </a:spcAft>
+              <a:defRPr sz="1100" b="1"/>
+            </a:pPr>
+            <a:r>
+              <a:t>Date of Circular:</a:t>
+            </a:r>
+          </a:p>
+          <a:p>
+            <a:pPr>
+              <a:spcBef>
+                <a:spcPts val="400"/>
+              </a:spcBef>
+              <a:spcAft>
+                <a:spcPts val="600"/>
+              </a:spcAft>
+              <a:defRPr sz="1100"/>
+            </a:pPr>
+            <a:r>
+              <a:t>2026-06-12</a:t>
+            </a:r>
+          </a:p>
+          <a:p>
+            <a:pPr>
+              <a:spcBef>
+                <a:spcPts val="1200"/>
+              </a:spcBef>
+              <a:spcAft>
+                <a:spcPts val="400"/>
+              </a:spcAft>
+              <a:defRPr sz="1100" b="1"/>
+            </a:pPr>
+            <a:r>
+              <a:t>Effective Date:</a:t>
+            </a:r>
+          </a:p>
+          <a:p>
+            <a:pPr>
+              <a:spcBef>
+                <a:spcPts val="400"/>
+              </a:spcBef>
+              <a:spcAft>
+                <a:spcPts val="600"/>
+              </a:spcAft>
+              <a:defRPr sz="1100"/>
+            </a:pPr>
+            <a:r>
+              <a:t>Not specified</a:t>
+            </a:r>
+          </a:p>
+        </p:txBody>
+      </p:sp>
+    </p:spTree>
+  </p:cSld>
+  <p:clrMapOvr>
+    <a:masterClrMapping/>
+  </p:clrMapOvr>
+</p:sld>
+</file>
+
+<file path=ppt/slides/slide13.xml><?xml version="1.0" encoding="utf-8"?>
+<p:sld xmlns:a="http://schemas.openxmlformats.org/drawingml/2006/main" xmlns:p="http://schemas.openxmlformats.org/presentationml/2006/main" xmlns:r="http://schemas.openxmlformats.org/officeDocument/2006/relationships">
+  <p:cSld>
+    <p:bg>
+      <p:bgPr>
+        <a:solidFill>
+          <a:srgbClr val="DBEDF3"/>
+        </a:solidFill>
+        <a:effectLst/>
+      </p:bgPr>
+    </p:bg>
+    <p:spTree>
+      <p:nvGrpSpPr>
+        <p:cNvPr id="1" name=""/>
+        <p:cNvGrpSpPr/>
+        <p:nvPr/>
+      </p:nvGrpSpPr>
+      <p:grpSpPr/>
+      <p:sp>
+        <p:nvSpPr>
+          <p:cNvPr id="9" name="Freeform 9">
+            <a:extLst>
+              <a:ext uri="{FF2B5EF4-FFF2-40B4-BE49-F238E27FC236}">
+                <a16:creationId xmlns:a16="http://schemas.microsoft.com/office/drawing/2014/main" id="{B2524028-2C9B-1404-BE53-33ADB3A2FCD5}"/>
+              </a:ext>
+            </a:extLst>
+          </p:cNvPr>
+          <p:cNvSpPr/>
+          <p:nvPr/>
+        </p:nvSpPr>
+        <p:spPr>
+          <a:xfrm>
+            <a:off x="0" y="91895"/>
+            <a:ext cx="7569820" cy="1433488"/>
+          </a:xfrm>
+          <a:custGeom>
+            <a:avLst/>
+            <a:gdLst/>
+            <a:ahLst/>
+            <a:cxnLst/>
+            <a:rect l="l" t="t" r="r" b="b"/>
+            <a:pathLst>
+              <a:path w="2712853" h="513730">
+                <a:moveTo>
+                  <a:pt x="0" y="0"/>
+                </a:moveTo>
+                <a:lnTo>
+                  <a:pt x="2712853" y="0"/>
+                </a:lnTo>
+                <a:lnTo>
+                  <a:pt x="2712853" y="513730"/>
+                </a:lnTo>
+                <a:lnTo>
+                  <a:pt x="0" y="513730"/>
+                </a:lnTo>
+                <a:close/>
+              </a:path>
+            </a:pathLst>
+          </a:custGeom>
+          <a:solidFill>
+            <a:schemeClr val="tx2"/>
+          </a:solidFill>
+        </p:spPr>
+        <p:txBody>
+          <a:bodyPr/>
+          <a:lstStyle/>
+          <a:p>
+            <a:pPr algn="ctr"/>
+            <a:endParaRPr lang="en-IN" sz="1800" b="1" u="sng" kern="100" dirty="0">
+              <a:solidFill>
+                <a:schemeClr val="bg1"/>
+              </a:solidFill>
+              <a:effectLst/>
+              <a:latin typeface="Calibri" panose="020F0502020204030204" pitchFamily="34" charset="0"/>
+              <a:ea typeface="Aptos" panose="020B0004020202020204" pitchFamily="34" charset="0"/>
+              <a:cs typeface="Times New Roman" panose="02020603050405020304" pitchFamily="18" charset="0"/>
+            </a:endParaRPr>
+          </a:p>
+          <a:p>
+            <a:pPr algn="ctr"/>
+            <a:endParaRPr lang="en-IN" b="1" u="sng" kern="100" dirty="0">
+              <a:solidFill>
+                <a:schemeClr val="bg1"/>
+              </a:solidFill>
+              <a:latin typeface="Calibri" panose="020F0502020204030204" pitchFamily="34" charset="0"/>
+              <a:ea typeface="Aptos" panose="020B0004020202020204" pitchFamily="34" charset="0"/>
+              <a:cs typeface="Times New Roman" panose="02020603050405020304" pitchFamily="18" charset="0"/>
+            </a:endParaRPr>
+          </a:p>
+          <a:p>
+            <a:pPr algn="ctr"/>
+            <a:r>
+              <a:rPr lang="en-IN" b="1" u="sng" kern="100" dirty="0">
+                <a:solidFill>
+                  <a:schemeClr val="bg1"/>
+                </a:solidFill>
+                <a:latin typeface="Calibri" panose="020F0502020204030204" pitchFamily="34" charset="0"/>
+                <a:ea typeface="Aptos" panose="020B0004020202020204" pitchFamily="34" charset="0"/>
+                <a:cs typeface="Times New Roman" panose="02020603050405020304" pitchFamily="18" charset="0"/>
+              </a:rPr>
+              <a:t>FOR LISTED ENTITIES </a:t>
+            </a:r>
+            <a:endParaRPr lang="en-IN" kern="100" dirty="0">
+              <a:solidFill>
+                <a:schemeClr val="bg1"/>
+              </a:solidFill>
+              <a:latin typeface="Aptos" panose="020B0004020202020204" pitchFamily="34" charset="0"/>
+              <a:ea typeface="Aptos" panose="020B0004020202020204" pitchFamily="34" charset="0"/>
+              <a:cs typeface="Times New Roman" panose="02020603050405020304" pitchFamily="18" charset="0"/>
+            </a:endParaRPr>
+          </a:p>
+          <a:p>
+            <a:pPr algn="ctr"/>
+            <a:endParaRPr lang="en-IN" b="1" u="sng" kern="100" dirty="0">
+              <a:solidFill>
+                <a:schemeClr val="bg1"/>
+              </a:solidFill>
+              <a:latin typeface="Calibri" panose="020F0502020204030204" pitchFamily="34" charset="0"/>
+              <a:ea typeface="Aptos" panose="020B0004020202020204" pitchFamily="34" charset="0"/>
+              <a:cs typeface="Times New Roman" panose="02020603050405020304" pitchFamily="18" charset="0"/>
+            </a:endParaRPr>
+          </a:p>
+          <a:p>
+            <a:pPr algn="ctr"/>
+            <a:endParaRPr lang="en-US" dirty="0"/>
+          </a:p>
+        </p:txBody>
+      </p:sp>
+      <p:grpSp>
+        <p:nvGrpSpPr>
+          <p:cNvPr id="11" name="Group 11">
+            <a:extLst>
+              <a:ext uri="{FF2B5EF4-FFF2-40B4-BE49-F238E27FC236}">
+                <a16:creationId xmlns:a16="http://schemas.microsoft.com/office/drawing/2014/main" id="{E2514E86-0813-FDB3-C8E1-A65BAC7CAF8B}"/>
+              </a:ext>
+            </a:extLst>
+          </p:cNvPr>
+          <p:cNvGrpSpPr/>
+          <p:nvPr/>
+        </p:nvGrpSpPr>
+        <p:grpSpPr>
+          <a:xfrm>
+            <a:off x="0" y="0"/>
+            <a:ext cx="7560000" cy="91895"/>
+            <a:chOff x="0" y="0"/>
+            <a:chExt cx="2709333" cy="32933"/>
+          </a:xfrm>
+          <a:solidFill>
+            <a:srgbClr val="00B0F0"/>
+          </a:solidFill>
+        </p:grpSpPr>
+        <p:sp>
+          <p:nvSpPr>
+            <p:cNvPr id="12" name="Freeform 12">
+              <a:extLst>
+                <a:ext uri="{FF2B5EF4-FFF2-40B4-BE49-F238E27FC236}">
+                  <a16:creationId xmlns:a16="http://schemas.microsoft.com/office/drawing/2014/main" id="{09FAB878-0211-ED08-EE38-35F69816CF24}"/>
+                </a:ext>
+              </a:extLst>
+            </p:cNvPr>
+            <p:cNvSpPr/>
+            <p:nvPr/>
+          </p:nvSpPr>
+          <p:spPr>
+            <a:xfrm>
+              <a:off x="0" y="0"/>
+              <a:ext cx="2709333" cy="32933"/>
+            </a:xfrm>
+            <a:custGeom>
+              <a:avLst/>
+              <a:gdLst/>
+              <a:ahLst/>
+              <a:cxnLst/>
+              <a:rect l="l" t="t" r="r" b="b"/>
+              <a:pathLst>
+                <a:path w="2709333" h="32933">
+                  <a:moveTo>
+                    <a:pt x="0" y="0"/>
+                  </a:moveTo>
+                  <a:lnTo>
+                    <a:pt x="2709333" y="0"/>
+                  </a:lnTo>
+                  <a:lnTo>
+                    <a:pt x="2709333" y="32933"/>
+                  </a:lnTo>
+                  <a:lnTo>
+                    <a:pt x="0" y="32933"/>
+                  </a:lnTo>
+                  <a:close/>
+                </a:path>
+              </a:pathLst>
+            </a:custGeom>
+            <a:grpFill/>
+          </p:spPr>
+          <p:txBody>
+            <a:bodyPr/>
+            <a:lstStyle/>
+            <a:p>
+              <a:endParaRPr lang="en-US"/>
+            </a:p>
+          </p:txBody>
+        </p:sp>
+        <p:sp>
+          <p:nvSpPr>
+            <p:cNvPr id="13" name="TextBox 13">
+              <a:extLst>
+                <a:ext uri="{FF2B5EF4-FFF2-40B4-BE49-F238E27FC236}">
+                  <a16:creationId xmlns:a16="http://schemas.microsoft.com/office/drawing/2014/main" id="{4B05D324-5046-D7D5-9841-5447C419D50D}"/>
+                </a:ext>
+              </a:extLst>
+            </p:cNvPr>
+            <p:cNvSpPr txBox="1"/>
+            <p:nvPr/>
+          </p:nvSpPr>
+          <p:spPr>
+            <a:xfrm>
+              <a:off x="0" y="-28575"/>
+              <a:ext cx="2709333" cy="61508"/>
+            </a:xfrm>
+            <a:prstGeom prst="rect">
+              <a:avLst/>
+            </a:prstGeom>
+            <a:grpFill/>
+          </p:spPr>
+          <p:txBody>
+            <a:bodyPr lIns="50800" tIns="50800" rIns="50800" bIns="50800" rtlCol="0" anchor="ctr"/>
+            <a:lstStyle/>
+            <a:p>
+              <a:pPr algn="ctr">
+                <a:lnSpc>
+                  <a:spcPts val="1960"/>
+                </a:lnSpc>
+                <a:spcBef>
+                  <a:spcPct val="0"/>
+                </a:spcBef>
+              </a:pPr>
+              <a:endParaRPr/>
+            </a:p>
+          </p:txBody>
+        </p:sp>
+      </p:grpSp>
+      <p:sp>
+        <p:nvSpPr>
+          <p:cNvPr id="14" name="TextBox 14">
+            <a:extLst>
+              <a:ext uri="{FF2B5EF4-FFF2-40B4-BE49-F238E27FC236}">
+                <a16:creationId xmlns:a16="http://schemas.microsoft.com/office/drawing/2014/main" id="{F0D261B9-C556-A210-8F75-69B5678B6DD0}"/>
+              </a:ext>
+            </a:extLst>
+          </p:cNvPr>
+          <p:cNvSpPr txBox="1"/>
+          <p:nvPr/>
+        </p:nvSpPr>
+        <p:spPr>
+          <a:xfrm>
+            <a:off x="120650" y="1617279"/>
+            <a:ext cx="7239000" cy="1383777"/>
+          </a:xfrm>
+          <a:prstGeom prst="rect">
+            <a:avLst/>
+          </a:prstGeom>
+        </p:spPr>
+        <p:txBody>
+          <a:bodyPr wrap="square" lIns="0" tIns="0" rIns="0" bIns="0" rtlCol="0" anchor="t">
+            <a:spAutoFit/>
+          </a:bodyPr>
+          <a:lstStyle/>
+          <a:p>
+            <a:pPr marL="342900" lvl="0" indent="-342900" algn="just">
+              <a:lnSpc>
+                <a:spcPct val="115000"/>
+              </a:lnSpc>
+              <a:spcAft>
+                <a:spcPts val="800"/>
+              </a:spcAft>
+              <a:buFont typeface="Wingdings" panose="05000000000000000000" pitchFamily="2" charset="2"/>
+              <a:buChar char=""/>
+            </a:pPr>
+            <a:endParaRPr lang="en-IN" sz="1600" b="1" u="sng" kern="100" dirty="0">
+              <a:solidFill>
+                <a:srgbClr val="002060"/>
+              </a:solidFill>
+              <a:effectLst/>
+              <a:ea typeface="Aptos" panose="020B0004020202020204" pitchFamily="34" charset="0"/>
+              <a:cs typeface="Times New Roman" panose="02020603050405020304" pitchFamily="18" charset="0"/>
+            </a:endParaRPr>
+          </a:p>
+          <a:p>
+            <a:pPr marL="742950" lvl="1" indent="-285750" algn="just">
+              <a:lnSpc>
+                <a:spcPct val="107000"/>
+              </a:lnSpc>
+              <a:spcAft>
+                <a:spcPts val="800"/>
+              </a:spcAft>
+              <a:buSzPts val="1000"/>
+              <a:buFont typeface="Courier New" panose="02070309020205020404" pitchFamily="49" charset="0"/>
+              <a:buChar char="o"/>
+              <a:tabLst>
+                <a:tab pos="914400" algn="l"/>
+              </a:tabLst>
+            </a:pPr>
+            <a:endParaRPr lang="en-IN" sz="1600" kern="100" dirty="0">
+              <a:effectLst/>
+              <a:ea typeface="Aptos" panose="020B0004020202020204" pitchFamily="34" charset="0"/>
+              <a:cs typeface="Times New Roman" panose="02020603050405020304" pitchFamily="18" charset="0"/>
+            </a:endParaRPr>
+          </a:p>
+          <a:p>
+            <a:pPr marL="342900" lvl="0" indent="-342900" algn="just">
+              <a:lnSpc>
+                <a:spcPct val="115000"/>
+              </a:lnSpc>
+              <a:spcAft>
+                <a:spcPts val="800"/>
+              </a:spcAft>
+              <a:buFont typeface="Wingdings" panose="05000000000000000000" pitchFamily="2" charset="2"/>
+              <a:buChar char=""/>
+            </a:pPr>
+            <a:endParaRPr lang="en-IN" sz="1600" b="1" u="sng" kern="100" dirty="0">
+              <a:effectLst/>
+              <a:ea typeface="Aptos" panose="020B0004020202020204" pitchFamily="34" charset="0"/>
+              <a:cs typeface="Times New Roman" panose="02020603050405020304" pitchFamily="18" charset="0"/>
+            </a:endParaRPr>
+          </a:p>
+          <a:p>
+            <a:pPr marL="285750" indent="-285750">
+              <a:spcAft>
+                <a:spcPts val="800"/>
+              </a:spcAft>
+              <a:buFont typeface="Arial" panose="020B0604020202020204" pitchFamily="34" charset="0"/>
+              <a:buChar char="•"/>
+            </a:pPr>
+            <a:endParaRPr lang="en-US" sz="1600" b="1" u="sng" spc="3" dirty="0">
+              <a:solidFill>
+                <a:srgbClr val="000000"/>
+              </a:solidFill>
+              <a:ea typeface="Montserrat Classic Bold"/>
+              <a:cs typeface="Montserrat Classic Bold"/>
+              <a:sym typeface="Montserrat Classic Bold"/>
+            </a:endParaRPr>
+          </a:p>
+        </p:txBody>
+      </p:sp>
+      <p:sp>
+        <p:nvSpPr>
+          <p:cNvPr id="15" name="TextBox 15">
+            <a:extLst>
+              <a:ext uri="{FF2B5EF4-FFF2-40B4-BE49-F238E27FC236}">
+                <a16:creationId xmlns:a16="http://schemas.microsoft.com/office/drawing/2014/main" id="{D0A12A1A-9265-659A-0EED-42FD4976DAAB}"/>
+              </a:ext>
+            </a:extLst>
+          </p:cNvPr>
+          <p:cNvSpPr txBox="1"/>
+          <p:nvPr/>
+        </p:nvSpPr>
+        <p:spPr>
+          <a:xfrm>
+            <a:off x="349250" y="10119945"/>
+            <a:ext cx="7081214" cy="186205"/>
+          </a:xfrm>
+          <a:prstGeom prst="rect">
+            <a:avLst/>
+          </a:prstGeom>
+        </p:spPr>
+        <p:txBody>
+          <a:bodyPr lIns="0" tIns="0" rIns="0" bIns="0" rtlCol="0" anchor="t">
+            <a:spAutoFit/>
+          </a:bodyPr>
+          <a:lstStyle/>
+          <a:p>
+            <a:pPr algn="ctr">
+              <a:lnSpc>
+                <a:spcPts val="1598"/>
+              </a:lnSpc>
+            </a:pPr>
+            <a:r>
+              <a:rPr lang="en-US" sz="1299" b="1" spc="3" dirty="0">
+                <a:solidFill>
+                  <a:schemeClr val="tx2">
+                    <a:lumMod val="60000"/>
+                    <a:lumOff val="40000"/>
+                    <a:alpha val="60000"/>
+                  </a:schemeClr>
+                </a:solidFill>
+                <a:latin typeface="Montserrat Classic Bold"/>
+                <a:ea typeface="Montserrat Classic Bold"/>
+                <a:cs typeface="Montserrat Classic Bold"/>
+                <a:sym typeface="Montserrat Classic Bold"/>
+              </a:rPr>
+              <a:t>Page 12 of 13</a:t>
+            </a:r>
+          </a:p>
+        </p:txBody>
+      </p:sp>
+      <p:pic>
+        <p:nvPicPr>
+          <p:cNvPr id="16" name="Picture 15" descr="image.png"/>
+          <p:cNvPicPr>
+            <a:picLocks noChangeAspect="1"/>
+          </p:cNvPicPr>
+          <p:nvPr/>
+        </p:nvPicPr>
+        <p:blipFill>
+          <a:blip r:embed="rId2"/>
+          <a:stretch>
+            <a:fillRect/>
+          </a:stretch>
+        </p:blipFill>
+        <p:spPr>
+          <a:xfrm>
+            <a:off x="5700611" y="387250"/>
+            <a:ext cx="1752600" cy="1067946"/>
+          </a:xfrm>
+          <a:prstGeom prst="rect">
+            <a:avLst/>
+          </a:prstGeom>
+        </p:spPr>
+      </p:pic>
+      <p:sp>
+        <p:nvSpPr>
+          <p:cNvPr id="8" name="Rectangle 1">
+            <a:extLst>
+              <a:ext uri="{FF2B5EF4-FFF2-40B4-BE49-F238E27FC236}">
+                <a16:creationId xmlns:a16="http://schemas.microsoft.com/office/drawing/2014/main" id="{DAAE1D69-07AD-34DE-A40D-39BC5927BFF2}"/>
+              </a:ext>
+            </a:extLst>
+          </p:cNvPr>
+          <p:cNvSpPr>
+            <a:spLocks noChangeArrowheads="1"/>
+          </p:cNvSpPr>
+          <p:nvPr/>
+        </p:nvSpPr>
+        <p:spPr bwMode="auto">
+          <a:xfrm>
+            <a:off x="434874" y="5474448"/>
+            <a:ext cx="6721977" cy="338554"/>
+          </a:xfrm>
+          <a:prstGeom prst="rect">
+            <a:avLst/>
+          </a:prstGeom>
+          <a:noFill/>
+          <a:ln>
+            <a:noFill/>
+          </a:ln>
+          <a:effectLst/>
+          <a:extLst>
+            <a:ext uri="{909E8E84-426E-40DD-AFC4-6F175D3DCCD1}">
+              <a14:hiddenFill xmlns:a14="http://schemas.microsoft.com/office/drawing/2010/main">
+                <a:solidFill>
+                  <a:schemeClr val="accent1"/>
+                </a:solidFill>
+              </a14:hiddenFill>
+            </a:ext>
+            <a:ext uri="{91240B29-F687-4F45-9708-019B960494DF}">
+              <a14:hiddenLine xmlns:a14="http://schemas.microsoft.com/office/drawing/2010/main" w="9525">
+                <a:solidFill>
+                  <a:schemeClr val="tx1"/>
+                </a:solidFill>
+                <a:miter lim="800000"/>
+                <a:headEnd/>
+                <a:tailEnd/>
+              </a14:hiddenLine>
+            </a:ext>
+            <a:ext uri="{AF507438-7753-43E0-B8FC-AC1667EBCBE1}">
+              <a14:hiddenEffects xmlns:a14="http://schemas.microsoft.com/office/drawing/2010/main">
+                <a:effectLst>
+                  <a:outerShdw dist="35921" dir="2700000" algn="ctr" rotWithShape="0">
+                    <a:schemeClr val="bg2"/>
+                  </a:outerShdw>
+                </a:effectLst>
+              </a14:hiddenEffects>
+            </a:ext>
+          </a:extLst>
+        </p:spPr>
+        <p:txBody>
+          <a:bodyPr vert="horz" wrap="square" lIns="91440" tIns="45720" rIns="91440" bIns="45720" numCol="1" anchor="ctr" anchorCtr="0" compatLnSpc="1">
+            <a:prstTxWarp prst="textNoShape">
+              <a:avLst/>
+            </a:prstTxWarp>
+            <a:spAutoFit/>
+          </a:bodyPr>
+          <a:lstStyle/>
+          <a:p>
+            <a:pPr marL="0" marR="0" lvl="0" indent="0" algn="just" defTabSz="914400" rtl="0" eaLnBrk="0" fontAlgn="base" latinLnBrk="0" hangingPunct="0">
+              <a:lnSpc>
+                <a:spcPct val="100000"/>
+              </a:lnSpc>
+              <a:spcBef>
+                <a:spcPct val="0"/>
+              </a:spcBef>
+              <a:spcAft>
+                <a:spcPct val="0"/>
+              </a:spcAft>
+              <a:buClrTx/>
+              <a:buSzTx/>
+              <a:buFontTx/>
+              <a:buNone/>
+              <a:tabLst/>
+            </a:pPr>
+            <a:r>
+              <a:rPr lang="en-US" altLang="en-US" sz="1600" dirty="0">
+                <a:solidFill>
+                  <a:srgbClr val="002060"/>
+                </a:solidFill>
+                <a:cs typeface="Calibri" panose="020F0502020204030204" pitchFamily="34" charset="0"/>
+              </a:rPr>
+              <a:t>.</a:t>
+            </a:r>
+          </a:p>
+        </p:txBody>
+      </p:sp>
+      <p:sp>
+        <p:nvSpPr>
+          <p:cNvPr id="10" name="Rectangle 2">
+            <a:extLst>
+              <a:ext uri="{FF2B5EF4-FFF2-40B4-BE49-F238E27FC236}">
+                <a16:creationId xmlns:a16="http://schemas.microsoft.com/office/drawing/2014/main" id="{E418F2FF-AB72-6152-EFFD-3BF109C49EDA}"/>
+              </a:ext>
+            </a:extLst>
+          </p:cNvPr>
+          <p:cNvSpPr>
+            <a:spLocks noChangeArrowheads="1"/>
+          </p:cNvSpPr>
+          <p:nvPr/>
+        </p:nvSpPr>
+        <p:spPr bwMode="auto">
+          <a:xfrm>
+            <a:off x="405196" y="6945974"/>
+            <a:ext cx="6746107" cy="338554"/>
+          </a:xfrm>
+          <a:prstGeom prst="rect">
+            <a:avLst/>
+          </a:prstGeom>
+          <a:noFill/>
+          <a:ln>
+            <a:noFill/>
+          </a:ln>
+          <a:effectLst/>
+          <a:extLst>
+            <a:ext uri="{909E8E84-426E-40DD-AFC4-6F175D3DCCD1}">
+              <a14:hiddenFill xmlns:a14="http://schemas.microsoft.com/office/drawing/2010/main">
+                <a:solidFill>
+                  <a:schemeClr val="accent1"/>
+                </a:solidFill>
+              </a14:hiddenFill>
+            </a:ext>
+            <a:ext uri="{91240B29-F687-4F45-9708-019B960494DF}">
+              <a14:hiddenLine xmlns:a14="http://schemas.microsoft.com/office/drawing/2010/main" w="9525">
+                <a:solidFill>
+                  <a:schemeClr val="tx1"/>
+                </a:solidFill>
+                <a:miter lim="800000"/>
+                <a:headEnd/>
+                <a:tailEnd/>
+              </a14:hiddenLine>
+            </a:ext>
+            <a:ext uri="{AF507438-7753-43E0-B8FC-AC1667EBCBE1}">
+              <a14:hiddenEffects xmlns:a14="http://schemas.microsoft.com/office/drawing/2010/main">
+                <a:effectLst>
+                  <a:outerShdw dist="35921" dir="2700000" algn="ctr" rotWithShape="0">
+                    <a:schemeClr val="bg2"/>
+                  </a:outerShdw>
+                </a:effectLst>
+              </a14:hiddenEffects>
+            </a:ext>
+          </a:extLst>
+        </p:spPr>
+        <p:txBody>
+          <a:bodyPr vert="horz" wrap="square" lIns="91440" tIns="45720" rIns="91440" bIns="45720" numCol="1" anchor="ctr" anchorCtr="0" compatLnSpc="1">
+            <a:prstTxWarp prst="textNoShape">
+              <a:avLst/>
+            </a:prstTxWarp>
+            <a:spAutoFit/>
+          </a:bodyPr>
+          <a:lstStyle>
+            <a:lvl1pPr eaLnBrk="0" fontAlgn="base" hangingPunct="0">
+              <a:spcBef>
+                <a:spcPct val="0"/>
+              </a:spcBef>
+              <a:spcAft>
+                <a:spcPct val="0"/>
+              </a:spcAft>
+              <a:tabLst>
+                <a:tab pos="457200" algn="l"/>
+              </a:tabLst>
+              <a:defRPr>
+                <a:solidFill>
+                  <a:schemeClr val="tx1"/>
+                </a:solidFill>
+                <a:latin typeface="Arial" panose="020B0604020202020204" pitchFamily="34" charset="0"/>
+              </a:defRPr>
+            </a:lvl1pPr>
+            <a:lvl2pPr eaLnBrk="0" fontAlgn="base" hangingPunct="0">
+              <a:spcBef>
+                <a:spcPct val="0"/>
+              </a:spcBef>
+              <a:spcAft>
+                <a:spcPct val="0"/>
+              </a:spcAft>
+              <a:tabLst>
+                <a:tab pos="457200" algn="l"/>
+              </a:tabLst>
+              <a:defRPr>
+                <a:solidFill>
+                  <a:schemeClr val="tx1"/>
+                </a:solidFill>
+                <a:latin typeface="Arial" panose="020B0604020202020204" pitchFamily="34" charset="0"/>
+              </a:defRPr>
+            </a:lvl2pPr>
+            <a:lvl3pPr eaLnBrk="0" fontAlgn="base" hangingPunct="0">
+              <a:spcBef>
+                <a:spcPct val="0"/>
+              </a:spcBef>
+              <a:spcAft>
+                <a:spcPct val="0"/>
+              </a:spcAft>
+              <a:tabLst>
+                <a:tab pos="457200" algn="l"/>
+              </a:tabLst>
+              <a:defRPr>
+                <a:solidFill>
+                  <a:schemeClr val="tx1"/>
+                </a:solidFill>
+                <a:latin typeface="Arial" panose="020B0604020202020204" pitchFamily="34" charset="0"/>
+              </a:defRPr>
+            </a:lvl3pPr>
+            <a:lvl4pPr eaLnBrk="0" fontAlgn="base" hangingPunct="0">
+              <a:spcBef>
+                <a:spcPct val="0"/>
+              </a:spcBef>
+              <a:spcAft>
+                <a:spcPct val="0"/>
+              </a:spcAft>
+              <a:tabLst>
+                <a:tab pos="457200" algn="l"/>
+              </a:tabLst>
+              <a:defRPr>
+                <a:solidFill>
+                  <a:schemeClr val="tx1"/>
+                </a:solidFill>
+                <a:latin typeface="Arial" panose="020B0604020202020204" pitchFamily="34" charset="0"/>
+              </a:defRPr>
+            </a:lvl4pPr>
+            <a:lvl5pPr eaLnBrk="0" fontAlgn="base" hangingPunct="0">
+              <a:spcBef>
+                <a:spcPct val="0"/>
+              </a:spcBef>
+              <a:spcAft>
+                <a:spcPct val="0"/>
+              </a:spcAft>
+              <a:tabLst>
+                <a:tab pos="457200" algn="l"/>
+              </a:tabLst>
+              <a:defRPr>
+                <a:solidFill>
+                  <a:schemeClr val="tx1"/>
+                </a:solidFill>
+                <a:latin typeface="Arial" panose="020B0604020202020204" pitchFamily="34" charset="0"/>
+              </a:defRPr>
+            </a:lvl5pPr>
+            <a:lvl6pPr eaLnBrk="0" fontAlgn="base" hangingPunct="0">
+              <a:spcBef>
+                <a:spcPct val="0"/>
+              </a:spcBef>
+              <a:spcAft>
+                <a:spcPct val="0"/>
+              </a:spcAft>
+              <a:tabLst>
+                <a:tab pos="457200" algn="l"/>
+              </a:tabLst>
+              <a:defRPr>
+                <a:solidFill>
+                  <a:schemeClr val="tx1"/>
+                </a:solidFill>
+                <a:latin typeface="Arial" panose="020B0604020202020204" pitchFamily="34" charset="0"/>
+              </a:defRPr>
+            </a:lvl6pPr>
+            <a:lvl7pPr eaLnBrk="0" fontAlgn="base" hangingPunct="0">
+              <a:spcBef>
+                <a:spcPct val="0"/>
+              </a:spcBef>
+              <a:spcAft>
+                <a:spcPct val="0"/>
+              </a:spcAft>
+              <a:tabLst>
+                <a:tab pos="457200" algn="l"/>
+              </a:tabLst>
+              <a:defRPr>
+                <a:solidFill>
+                  <a:schemeClr val="tx1"/>
+                </a:solidFill>
+                <a:latin typeface="Arial" panose="020B0604020202020204" pitchFamily="34" charset="0"/>
+              </a:defRPr>
+            </a:lvl7pPr>
+            <a:lvl8pPr eaLnBrk="0" fontAlgn="base" hangingPunct="0">
+              <a:spcBef>
+                <a:spcPct val="0"/>
+              </a:spcBef>
+              <a:spcAft>
+                <a:spcPct val="0"/>
+              </a:spcAft>
+              <a:tabLst>
+                <a:tab pos="457200" algn="l"/>
+              </a:tabLst>
+              <a:defRPr>
+                <a:solidFill>
+                  <a:schemeClr val="tx1"/>
+                </a:solidFill>
+                <a:latin typeface="Arial" panose="020B0604020202020204" pitchFamily="34" charset="0"/>
+              </a:defRPr>
+            </a:lvl8pPr>
+            <a:lvl9pPr eaLnBrk="0" fontAlgn="base" hangingPunct="0">
+              <a:spcBef>
+                <a:spcPct val="0"/>
+              </a:spcBef>
+              <a:spcAft>
+                <a:spcPct val="0"/>
+              </a:spcAft>
+              <a:tabLst>
+                <a:tab pos="457200" algn="l"/>
+              </a:tabLst>
+              <a:defRPr>
+                <a:solidFill>
+                  <a:schemeClr val="tx1"/>
+                </a:solidFill>
+                <a:latin typeface="Arial" panose="020B0604020202020204" pitchFamily="34" charset="0"/>
+              </a:defRPr>
+            </a:lvl9pPr>
+          </a:lstStyle>
+          <a:p>
+            <a:pPr marL="0" marR="0" lvl="0" indent="0" algn="just" defTabSz="914400" rtl="0" eaLnBrk="0" fontAlgn="base" latinLnBrk="0" hangingPunct="0">
+              <a:lnSpc>
+                <a:spcPct val="100000"/>
+              </a:lnSpc>
+              <a:spcBef>
+                <a:spcPct val="0"/>
+              </a:spcBef>
+              <a:spcAft>
+                <a:spcPct val="0"/>
+              </a:spcAft>
+              <a:buClrTx/>
+              <a:buSzTx/>
+              <a:buFontTx/>
+              <a:buNone/>
+              <a:tabLst>
+                <a:tab pos="457200" algn="l"/>
+              </a:tabLst>
+            </a:pPr>
+            <a:r>
+              <a:rPr lang="en-US" altLang="en-US" sz="1600" dirty="0">
+                <a:solidFill>
+                  <a:srgbClr val="002060"/>
+                </a:solidFill>
+                <a:latin typeface="+mn-lt"/>
+                <a:cs typeface="Calibri" panose="020F0502020204030204" pitchFamily="34" charset="0"/>
+              </a:rPr>
+              <a:t>.</a:t>
+            </a:r>
+          </a:p>
+        </p:txBody>
+      </p:sp>
+      <p:sp>
+        <p:nvSpPr>
+          <p:cNvPr id="2" name="Slide Number Placeholder 1">
+            <a:extLst>
+              <a:ext uri="{FF2B5EF4-FFF2-40B4-BE49-F238E27FC236}">
+                <a16:creationId xmlns:a16="http://schemas.microsoft.com/office/drawing/2014/main" id="{73BF2278-C9D9-6969-211F-206FF6E49823}"/>
+              </a:ext>
+            </a:extLst>
+          </p:cNvPr>
+          <p:cNvSpPr>
+            <a:spLocks noGrp="1"/>
+          </p:cNvSpPr>
+          <p:nvPr>
+            <p:ph type="sldNum" sz="quarter" idx="12"/>
+          </p:nvPr>
+        </p:nvSpPr>
+        <p:spPr/>
+        <p:txBody>
+          <a:bodyPr/>
+          <a:lstStyle/>
+          <a:p>
+            <a:fld id="{B6F15528-21DE-4FAA-801E-634DDDAF4B2B}" type="slidenum">
+              <a:rPr lang="en-US" smtClean="0"/>
+              <a:pPr/>
+              <a:t>10</a:t>
+            </a:fld>
+            <a:endParaRPr lang="en-US" dirty="0"/>
+          </a:p>
+        </p:txBody>
+      </p:sp>
+      <p:sp>
+        <p:nvSpPr>
+          <p:cNvPr id="17" name="TextBox 16"/>
+          <p:cNvSpPr txBox="1"/>
+          <p:nvPr/>
+        </p:nvSpPr>
+        <p:spPr>
+          <a:xfrm>
+            <a:off x="457200" y="1828800"/>
+            <a:ext cx="6583680" cy="3227832"/>
+          </a:xfrm>
+          <a:prstGeom prst="rect">
+            <a:avLst/>
+          </a:prstGeom>
+          <a:noFill/>
+        </p:spPr>
+        <p:txBody>
+          <a:bodyPr wrap="square">
+            <a:spAutoFit/>
+          </a:bodyPr>
+          <a:lstStyle/>
+          <a:p>
+            <a:pPr>
+              <a:spcBef>
+                <a:spcPts val="1200"/>
+              </a:spcBef>
+              <a:spcAft>
+                <a:spcPts val="400"/>
+              </a:spcAft>
+              <a:defRPr sz="1100" b="1"/>
+            </a:pPr>
+            <a:r>
+              <a:t>Gist of amendment:</a:t>
+            </a:r>
+          </a:p>
+          <a:p>
+            <a:pPr>
+              <a:spcBef>
+                <a:spcPts val="400"/>
+              </a:spcBef>
+              <a:spcAft>
+                <a:spcPts val="600"/>
+              </a:spcAft>
+              <a:defRPr sz="1100"/>
+            </a:pPr>
+            <a:r>
+              <a:t>BSE has issued this circular and Issued a circular titled "Frequently Asked Questions (FAQs) on the submission of the Quarterly Integrated Filing  -  Governance." This circular modifies the submission process for the Integrated Filing  -  Governance, formerly known as Corporate Governance Report.</a:t>
+            </a:r>
+          </a:p>
+          <a:p>
+            <a:pPr>
+              <a:spcBef>
+                <a:spcPts val="1200"/>
+              </a:spcBef>
+              <a:spcAft>
+                <a:spcPts val="400"/>
+              </a:spcAft>
+              <a:defRPr sz="1100" b="1"/>
+            </a:pPr>
+            <a:r>
+              <a:t>Submission of disclosures:</a:t>
+            </a:r>
+          </a:p>
+          <a:p>
+            <a:pPr>
+              <a:spcBef>
+                <a:spcPts val="400"/>
+              </a:spcBef>
+              <a:spcAft>
+                <a:spcPts val="600"/>
+              </a:spcAft>
+              <a:defRPr sz="1100"/>
+            </a:pPr>
+            <a:r>
+              <a:t>Listing Centre - To submit the Quarterly Integrated Filing  -  Governance, refer to the listed entities' regular filing workflow.</a:t>
+            </a:r>
+          </a:p>
+          <a:p>
+            <a:pPr>
+              <a:spcBef>
+                <a:spcPts val="400"/>
+              </a:spcBef>
+              <a:spcAft>
+                <a:spcPts val="600"/>
+              </a:spcAft>
+              <a:defRPr sz="1100"/>
+            </a:pPr>
+            <a:r>
+              <a:t>The submissions must be in XBRL mode only. No PDF files are accepted.</a:t>
+            </a:r>
+          </a:p>
+          <a:p>
+            <a:pPr>
+              <a:spcBef>
+                <a:spcPts val="0"/>
+              </a:spcBef>
+              <a:spcAft>
+                <a:spcPts val="200"/>
+              </a:spcAft>
+              <a:defRPr sz="1100"/>
+            </a:pPr>
+            <a:r>
+              <a:t>- If any unlisted fiduciaries have queries or issues, they can contact Listing Compliance and Operations through email at [email protected]</a:t>
+            </a:r>
+          </a:p>
+          <a:p>
+            <a:pPr>
+              <a:spcBef>
+                <a:spcPts val="0"/>
+              </a:spcBef>
+              <a:spcAft>
+                <a:spcPts val="200"/>
+              </a:spcAft>
+              <a:defRPr sz="1100"/>
+            </a:pPr>
+            <a:r>
+              <a:t>- The legacy paths for Corporate Governance Report submission are now discontinued.</a:t>
+            </a:r>
+          </a:p>
+          <a:p>
+            <a:pPr>
+              <a:spcBef>
+                <a:spcPts val="0"/>
+              </a:spcBef>
+              <a:spcAft>
+                <a:spcPts val="200"/>
+              </a:spcAft>
+              <a:defRPr sz="1100"/>
+            </a:pPr>
+            <a:r>
+              <a:t>- Submissions via alternative routes (other than the regular filing workflow) are considered invalid.</a:t>
             </a:r>
           </a:p>
         </p:txBody>
@@ -7724,7 +8838,9 @@
         <p:txBody>
           <a:bodyPr/>
           <a:lstStyle/>
-          <a:p/>
+          <a:p>
+            <a:endParaRPr lang="en-US" dirty="0"/>
+          </a:p>
         </p:txBody>
       </p:sp>
       <p:grpSp>
@@ -7843,9 +8959,30 @@
           </a:bodyPr>
           <a:lstStyle/>
           <a:p>
-            <a:r>
+            <a:pPr algn="just">
+              <a:spcAft>
+                <a:spcPts val="800"/>
+              </a:spcAft>
+              <a:buNone/>
+            </a:pPr>
+            <a:r>
+              <a:rPr lang="en-IN" sz="1600" kern="100" dirty="0">
+                <a:effectLst/>
+                <a:latin typeface="Aptos" panose="020B0004020202020204" pitchFamily="34" charset="0"/>
+                <a:ea typeface="Aptos" panose="020B0004020202020204" pitchFamily="34" charset="0"/>
+                <a:cs typeface="Times New Roman" panose="02020603050405020304" pitchFamily="18" charset="0"/>
+              </a:rPr>
               <a:t> </a:t>
             </a:r>
+            <a:endParaRPr lang="en-US" sz="1200" b="1" spc="3" dirty="0">
+              <a:solidFill>
+                <a:srgbClr val="000000"/>
+              </a:solidFill>
+              <a:latin typeface="Montserrat Classic Bold"/>
+              <a:ea typeface="Montserrat Classic Bold"/>
+              <a:cs typeface="Montserrat Classic Bold"/>
+              <a:sym typeface="Montserrat Classic Bold"/>
+            </a:endParaRPr>
           </a:p>
         </p:txBody>
       </p:sp>
@@ -7870,11 +9007,60 @@
           </a:bodyPr>
           <a:lstStyle/>
           <a:p>
-            <a:r>
-              <a:t> Page 2 of 12</a:t>
-            </a:r>
-          </a:p>
-          <a:p/>
+            <a:pPr algn="ctr">
+              <a:lnSpc>
+                <a:spcPts val="1598"/>
+              </a:lnSpc>
+            </a:pPr>
+            <a:r>
+              <a:rPr lang="en-US" sz="1299" b="1" spc="3" dirty="0">
+                <a:solidFill>
+                  <a:srgbClr val="FFFFFF">
+                    <a:alpha val="60000"/>
+                  </a:srgbClr>
+                </a:solidFill>
+                <a:latin typeface="Montserrat Classic Bold"/>
+                <a:ea typeface="Montserrat Classic Bold"/>
+                <a:cs typeface="Montserrat Classic Bold"/>
+                <a:sym typeface="Montserrat Classic Bold"/>
+              </a:rPr>
+              <a:t> </a:t>
+            </a:r>
+            <a:r>
+              <a:rPr lang="en-US" sz="1299" b="1" spc="3" dirty="0">
+                <a:solidFill>
+                  <a:schemeClr val="tx2">
+                    <a:lumMod val="60000"/>
+                    <a:lumOff val="40000"/>
+                    <a:alpha val="60000"/>
+                  </a:schemeClr>
+                </a:solidFill>
+                <a:latin typeface="Montserrat Classic Bold"/>
+                <a:ea typeface="Montserrat Classic Bold"/>
+                <a:cs typeface="Montserrat Classic Bold"/>
+                <a:sym typeface="Montserrat Classic Bold"/>
+              </a:rPr>
+              <a:t>Page 2 of 13</a:t>
+            </a:r>
+          </a:p>
+          <a:p>
+            <a:pPr algn="ctr">
+              <a:lnSpc>
+                <a:spcPts val="1598"/>
+              </a:lnSpc>
+            </a:pPr>
+            <a:endParaRPr lang="en-US" sz="1299" b="1" spc="3" dirty="0">
+              <a:solidFill>
+                <a:srgbClr val="FFFFFF">
+                  <a:alpha val="60000"/>
+                </a:srgbClr>
+              </a:solidFill>
+              <a:latin typeface="Montserrat Classic Bold"/>
+              <a:ea typeface="Montserrat Classic Bold"/>
+              <a:cs typeface="Montserrat Classic Bold"/>
+              <a:sym typeface="Montserrat Classic Bold"/>
+            </a:endParaRPr>
+          </a:p>
         </p:txBody>
       </p:sp>
       <p:sp>
@@ -7906,7 +9092,7 @@
           <a:lstStyle/>
           <a:p>
             <a:r>
-              <a:t>This edition captures key updates from Listed Companies and SEBI issued during June, grouped by relevance to ensure actionable insights. Our aim is to support your governance journey and reinforce transparency across your operations.</a:t>
+              <a:t>This edition captures key updates from SEBI and Listed Companies issued during June, grouped by relevance to ensure actionable insights. Our aim is to support your governance journey and reinforce transparency across your operations.</a:t>
             </a:r>
           </a:p>
           <a:p>
@@ -7955,7 +9141,18 @@
             <a:spAutoFit/>
           </a:bodyPr>
           <a:lstStyle/>
-          <a:p/>
+          <a:p>
+            <a:pPr lvl="0" algn="just">
+              <a:lnSpc>
+                <a:spcPct val="115000"/>
+              </a:lnSpc>
+            </a:pPr>
+            <a:endParaRPr lang="en-IN" sz="1600" kern="100" dirty="0">
+              <a:effectLst/>
+              <a:ea typeface="Aptos" panose="020B0004020202020204" pitchFamily="34" charset="0"/>
+              <a:cs typeface="Times New Roman" panose="02020603050405020304" pitchFamily="18" charset="0"/>
+            </a:endParaRPr>
+          </a:p>
         </p:txBody>
       </p:sp>
       <p:sp>
@@ -7980,9 +9177,31 @@
           <a:bodyPr lIns="50800" tIns="50800" rIns="50800" bIns="50800" rtlCol="0" anchor="ctr"/>
           <a:lstStyle/>
           <a:p>
-            <a:r>
+            <a:pPr algn="ctr">
+              <a:lnSpc>
+                <a:spcPts val="1960"/>
+              </a:lnSpc>
+            </a:pPr>
+            <a:r>
+              <a:rPr lang="en-IN" sz="2800" b="1" u="sng" kern="100">
+                <a:solidFill>
+                  <a:schemeClr val="bg1"/>
+                </a:solidFill>
+                <a:latin typeface="Calibri" panose="020F0502020204030204" pitchFamily="34" charset="0"/>
+                <a:ea typeface="Aptos" panose="020B0004020202020204" pitchFamily="34" charset="0"/>
+                <a:cs typeface="Times New Roman" panose="02020603050405020304" pitchFamily="18" charset="0"/>
+              </a:rPr>
               <a:t>INDEX</a:t>
             </a:r>
+            <a:endParaRPr lang="en-IN" sz="1800" kern="100" dirty="0">
+              <a:solidFill>
+                <a:schemeClr val="bg1"/>
+              </a:solidFill>
+              <a:effectLst/>
+              <a:latin typeface="Aptos" panose="020B0004020202020204" pitchFamily="34" charset="0"/>
+              <a:ea typeface="Aptos" panose="020B0004020202020204" pitchFamily="34" charset="0"/>
+              <a:cs typeface="Times New Roman" panose="02020603050405020304" pitchFamily="18" charset="0"/>
+            </a:endParaRPr>
           </a:p>
         </p:txBody>
       </p:sp>
@@ -8037,9 +9256,12 @@
           <a:bodyPr/>
           <a:lstStyle/>
           <a:p>
-            <a:r>
+            <a:fld id="{B6F15528-21DE-4FAA-801E-634DDDAF4B2B}" type="slidenum">
+              <a:rPr lang="en-US" smtClean="0"/>
+              <a:pPr/>
               <a:t>2</a:t>
-            </a:r>
+            </a:fld>
+            <a:endParaRPr lang="en-US" dirty="0"/>
           </a:p>
         </p:txBody>
       </p:sp>
@@ -8064,41 +9286,6 @@
             <a:spAutoFit/>
           </a:bodyPr>
           <a:lstStyle/>
-          <a:p>
-            <a:br/>
-            <a:pPr>
-              <a:defRPr b="1" u="sng" sz="1600">
-                <a:solidFill>
-                  <a:srgbClr val="002060"/>
-                </a:solidFill>
-              </a:defRPr>
-            </a:pPr>
-            <a:r>
-              <a:t>CIRCULAR-BSE:</a:t>
-            </a:r>
-          </a:p>
-          <a:p>
-            <a:pPr>
-              <a:spcAft>
-                <a:spcPts val="600"/>
-              </a:spcAft>
-              <a:defRPr sz="1200"/>
-            </a:pPr>
-            <a:r>
-              <a:t>➢ Pre-Packaged Insolvency Resolution Process under Section 54L of the Insolvency and Bankruptcy Code, 2016</a:t>
-            </a:r>
-          </a:p>
-          <a:p>
-            <a:pPr>
-              <a:spcAft>
-                <a:spcPts val="600"/>
-              </a:spcAft>
-              <a:defRPr sz="1200"/>
-            </a:pPr>
-            <a:r>
-              <a:t>➢ Frequently Asked Questions (FAQs) on the submission of the Quarterly Integrated Filing – Governance</a:t>
-            </a:r>
-          </a:p>
           <a:p>
             <a:br/>
             <a:pPr>
@@ -8302,7 +9489,9 @@
         <p:txBody>
           <a:bodyPr/>
           <a:lstStyle/>
-          <a:p/>
+          <a:p>
+            <a:endParaRPr lang="en-US" dirty="0"/>
+          </a:p>
         </p:txBody>
       </p:sp>
       <p:grpSp>
@@ -8445,9 +9634,30 @@
           </a:bodyPr>
           <a:lstStyle/>
           <a:p>
-            <a:r>
+            <a:pPr algn="just">
+              <a:spcAft>
+                <a:spcPts val="800"/>
+              </a:spcAft>
+              <a:buNone/>
+            </a:pPr>
+            <a:r>
+              <a:rPr lang="en-IN" sz="1600" kern="100" dirty="0">
+                <a:effectLst/>
+                <a:latin typeface="Aptos" panose="020B0004020202020204" pitchFamily="34" charset="0"/>
+                <a:ea typeface="Aptos" panose="020B0004020202020204" pitchFamily="34" charset="0"/>
+                <a:cs typeface="Times New Roman" panose="02020603050405020304" pitchFamily="18" charset="0"/>
+              </a:rPr>
               <a:t> </a:t>
             </a:r>
+            <a:endParaRPr lang="en-US" sz="1200" b="1" spc="3" dirty="0">
+              <a:solidFill>
+                <a:srgbClr val="000000"/>
+              </a:solidFill>
+              <a:latin typeface="Montserrat Classic Bold"/>
+              <a:ea typeface="Montserrat Classic Bold"/>
+              <a:cs typeface="Montserrat Classic Bold"/>
+              <a:sym typeface="Montserrat Classic Bold"/>
+            </a:endParaRPr>
           </a:p>
         </p:txBody>
       </p:sp>
@@ -8478,11 +9688,60 @@
           </a:bodyPr>
           <a:lstStyle/>
           <a:p>
-            <a:r>
-              <a:t> Page 3 of 12 </a:t>
-            </a:r>
-          </a:p>
-          <a:p/>
+            <a:pPr algn="ctr">
+              <a:lnSpc>
+                <a:spcPts val="1598"/>
+              </a:lnSpc>
+            </a:pPr>
+            <a:r>
+              <a:rPr lang="en-US" sz="1299" b="1" spc="3" dirty="0">
+                <a:solidFill>
+                  <a:srgbClr val="FFFFFF">
+                    <a:alpha val="60000"/>
+                  </a:srgbClr>
+                </a:solidFill>
+                <a:latin typeface="Montserrat Classic Bold"/>
+                <a:ea typeface="Montserrat Classic Bold"/>
+                <a:cs typeface="Montserrat Classic Bold"/>
+                <a:sym typeface="Montserrat Classic Bold"/>
+              </a:rPr>
+              <a:t> </a:t>
+            </a:r>
+            <a:r>
+              <a:rPr lang="en-US" sz="1299" b="1" spc="3" dirty="0">
+                <a:solidFill>
+                  <a:schemeClr val="tx2">
+                    <a:lumMod val="60000"/>
+                    <a:lumOff val="40000"/>
+                    <a:alpha val="60000"/>
+                  </a:schemeClr>
+                </a:solidFill>
+                <a:latin typeface="Montserrat Classic Bold"/>
+                <a:ea typeface="Montserrat Classic Bold"/>
+                <a:cs typeface="Montserrat Classic Bold"/>
+                <a:sym typeface="Montserrat Classic Bold"/>
+              </a:rPr>
+              <a:t>Page 3 of 13 </a:t>
+            </a:r>
+          </a:p>
+          <a:p>
+            <a:pPr algn="ctr">
+              <a:lnSpc>
+                <a:spcPts val="1598"/>
+              </a:lnSpc>
+            </a:pPr>
+            <a:endParaRPr lang="en-US" sz="1299" b="1" spc="3" dirty="0">
+              <a:solidFill>
+                <a:srgbClr val="FFFFFF">
+                  <a:alpha val="60000"/>
+                </a:srgbClr>
+              </a:solidFill>
+              <a:latin typeface="Montserrat Classic Bold"/>
+              <a:ea typeface="Montserrat Classic Bold"/>
+              <a:cs typeface="Montserrat Classic Bold"/>
+              <a:sym typeface="Montserrat Classic Bold"/>
+            </a:endParaRPr>
+          </a:p>
         </p:txBody>
       </p:sp>
       <p:sp>
@@ -8512,8 +9771,40 @@
             <a:spAutoFit/>
           </a:bodyPr>
           <a:lstStyle/>
-          <a:p/>
-          <a:p/>
+          <a:p>
+            <a:pPr marL="285750" indent="-285750">
+              <a:lnSpc>
+                <a:spcPct val="150000"/>
+              </a:lnSpc>
+              <a:spcAft>
+                <a:spcPts val="800"/>
+              </a:spcAft>
+              <a:buFont typeface="Arial" panose="020B0604020202020204" pitchFamily="34" charset="0"/>
+              <a:buChar char="•"/>
+            </a:pPr>
+            <a:endParaRPr lang="en-US" sz="1600" b="1" u="sng" kern="100" dirty="0">
+              <a:solidFill>
+                <a:srgbClr val="002060"/>
+              </a:solidFill>
+              <a:cs typeface="Times New Roman" panose="02020603050405020304" pitchFamily="18" charset="0"/>
+            </a:endParaRPr>
+          </a:p>
+          <a:p>
+            <a:pPr algn="just">
+              <a:lnSpc>
+                <a:spcPct val="150000"/>
+              </a:lnSpc>
+              <a:spcAft>
+                <a:spcPts val="800"/>
+              </a:spcAft>
+            </a:pPr>
+            <a:endParaRPr lang="en-US" sz="1600" kern="100" dirty="0">
+              <a:solidFill>
+                <a:srgbClr val="002060"/>
+              </a:solidFill>
+              <a:cs typeface="Times New Roman" panose="02020603050405020304" pitchFamily="18" charset="0"/>
+            </a:endParaRPr>
+          </a:p>
         </p:txBody>
       </p:sp>
       <p:sp>
@@ -8543,7 +9834,18 @@
             <a:spAutoFit/>
           </a:bodyPr>
           <a:lstStyle/>
-          <a:p/>
+          <a:p>
+            <a:pPr lvl="0" algn="just">
+              <a:lnSpc>
+                <a:spcPct val="115000"/>
+              </a:lnSpc>
+            </a:pPr>
+            <a:endParaRPr lang="en-IN" sz="1600" kern="100" dirty="0">
+              <a:effectLst/>
+              <a:ea typeface="Aptos" panose="020B0004020202020204" pitchFamily="34" charset="0"/>
+              <a:cs typeface="Times New Roman" panose="02020603050405020304" pitchFamily="18" charset="0"/>
+            </a:endParaRPr>
+          </a:p>
         </p:txBody>
       </p:sp>
       <p:sp>
@@ -8574,9 +9876,31 @@
           <a:bodyPr lIns="50800" tIns="50800" rIns="50800" bIns="50800" rtlCol="0" anchor="ctr"/>
           <a:lstStyle/>
           <a:p>
-            <a:r>
+            <a:pPr algn="ctr">
+              <a:lnSpc>
+                <a:spcPts val="1960"/>
+              </a:lnSpc>
+            </a:pPr>
+            <a:r>
+              <a:rPr lang="en-IN" sz="2800" b="1" u="sng" kern="100">
+                <a:solidFill>
+                  <a:schemeClr val="bg1"/>
+                </a:solidFill>
+                <a:latin typeface="Calibri" panose="020F0502020204030204" pitchFamily="34" charset="0"/>
+                <a:ea typeface="Aptos" panose="020B0004020202020204" pitchFamily="34" charset="0"/>
+                <a:cs typeface="Times New Roman" panose="02020603050405020304" pitchFamily="18" charset="0"/>
+              </a:rPr>
               <a:t>INDEX</a:t>
             </a:r>
+            <a:endParaRPr lang="en-IN" sz="1800" kern="100" dirty="0">
+              <a:solidFill>
+                <a:schemeClr val="bg1"/>
+              </a:solidFill>
+              <a:effectLst/>
+              <a:latin typeface="Aptos" panose="020B0004020202020204" pitchFamily="34" charset="0"/>
+              <a:ea typeface="Aptos" panose="020B0004020202020204" pitchFamily="34" charset="0"/>
+              <a:cs typeface="Times New Roman" panose="02020603050405020304" pitchFamily="18" charset="0"/>
+            </a:endParaRPr>
           </a:p>
         </p:txBody>
       </p:sp>
@@ -8631,9 +9955,12 @@
           <a:bodyPr/>
           <a:lstStyle/>
           <a:p>
-            <a:r>
+            <a:fld id="{B6F15528-21DE-4FAA-801E-634DDDAF4B2B}" type="slidenum">
+              <a:rPr lang="en-US" smtClean="0"/>
+              <a:pPr/>
               <a:t>3</a:t>
-            </a:r>
+            </a:fld>
+            <a:endParaRPr lang="en-US"/>
           </a:p>
         </p:txBody>
       </p:sp>
@@ -8680,6 +10007,41 @@
             </a:pPr>
             <a:r>
               <a:t>➢ Request for Informal Guidance by way of an "interpretive letter" under under the Securities and Exchange Board of India (Informal Guidance) Scheme, 2025 received from Maithan Alloys Limited seeking interpretation of the provisions of Regulation 16(1)(b)(iii) of Securities and Exchange Board of India (Listing Obligations and Disclosure Requirements/) Regulations, 2015.</a:t>
+            </a:r>
+          </a:p>
+          <a:p>
+            <a:br/>
+            <a:pPr>
+              <a:defRPr b="1" u="sng" sz="1600">
+                <a:solidFill>
+                  <a:srgbClr val="002060"/>
+                </a:solidFill>
+              </a:defRPr>
+            </a:pPr>
+            <a:r>
+              <a:t>CIRCULAR-BSE:</a:t>
+            </a:r>
+          </a:p>
+          <a:p>
+            <a:pPr>
+              <a:spcAft>
+                <a:spcPts val="600"/>
+              </a:spcAft>
+              <a:defRPr sz="1200"/>
+            </a:pPr>
+            <a:r>
+              <a:t>➢ Pre-Packaged Insolvency Resolution Process under Section 54L of the Insolvency and Bankruptcy Code, 2016</a:t>
+            </a:r>
+          </a:p>
+          <a:p>
+            <a:pPr>
+              <a:spcAft>
+                <a:spcPts val="600"/>
+              </a:spcAft>
+              <a:defRPr sz="1200"/>
+            </a:pPr>
+            <a:r>
+              <a:t>➢ Frequently Asked Questions (FAQs) on the submission of the Quarterly Integrated Filing – Governance</a:t>
             </a:r>
           </a:p>
         </p:txBody>
@@ -9086,7 +10448,7 @@
                 <a:cs typeface="Montserrat Classic Bold"/>
                 <a:sym typeface="Montserrat Classic Bold"/>
               </a:rPr>
-              <a:t>Page 4 of 12</a:t>
+              <a:t>Page 4 of 13</a:t>
             </a:r>
           </a:p>
         </p:txBody>
@@ -9416,7 +10778,7 @@
                 <a:cs typeface="Montserrat Classic Bold"/>
                 <a:sym typeface="Montserrat Classic Bold"/>
               </a:rPr>
-              <a:t>Page 5 of 12</a:t>
+              <a:t>Page 5 of 13</a:t>
             </a:r>
           </a:p>
           <a:p>
@@ -9813,7 +11175,7 @@
               </a:defRPr>
             </a:pPr>
             <a:r>
-              <a:t>➤ CIRCULAR-BSE</a:t>
+              <a:t>➤ PRESS RELEASE</a:t>
             </a:r>
           </a:p>
         </p:txBody>
@@ -9827,7 +11189,7 @@
         <p:spPr>
           <a:xfrm>
             <a:off x="457200" y="2286000"/>
-            <a:ext cx="6583680" cy="5239512"/>
+            <a:ext cx="6583680" cy="2249424"/>
           </a:xfrm>
           <a:prstGeom prst="rect">
             <a:avLst/>
@@ -9852,189 +11214,49 @@
                 </a:solidFill>
                 <a:hlinkClick r:id="rId3"/>
               </a:rPr>
-              <a:t>Pre-Packaged Insolvency Resolution Process under Section 54L of the Insolvency and Bankruptcy Code, 2016</a:t>
+              <a:t>Constitution of an Expert Working Group on review of extant regulatory framework applicable for Debenture Trusteeship activities and other incidental matters</a:t>
             </a:r>
           </a:p>
           <a:p>
             <a:pPr>
               <a:spcBef>
-                <a:spcPts val="1200"/>
-              </a:spcBef>
-              <a:spcAft>
-                <a:spcPts val="400"/>
-              </a:spcAft>
-              <a:defRPr sz="1100" b="1"/>
-            </a:pPr>
-            <a:r>
-              <a:t>Date of Circular:</a:t>
+                <a:spcPts val="0"/>
+              </a:spcBef>
+              <a:spcAft>
+                <a:spcPts val="200"/>
+              </a:spcAft>
+              <a:defRPr sz="1100"/>
+            </a:pPr>
+            <a:r>
+              <a:t>- The press release issued states that SEBI has constituted an Expert Working Group to review the regulatory framework applicable for Debenture Trusteeship activities, aiming to align it with changing market dynamics.</a:t>
             </a:r>
           </a:p>
           <a:p>
             <a:pPr>
               <a:spcBef>
-                <a:spcPts val="400"/>
-              </a:spcBef>
-              <a:spcAft>
-                <a:spcPts val="600"/>
+                <a:spcPts val="0"/>
+              </a:spcBef>
+              <a:spcAft>
+                <a:spcPts val="200"/>
               </a:spcAft>
               <a:defRPr sz="1100"/>
             </a:pPr>
             <a:r>
-              <a:t>2026-06-01</a:t>
+              <a:t>- The Working Group will examine representations and suggestions from market participants, recommend measures to strengthen Debenture Trustee roles, review net-worth requirements, and consider other relevant matters related to debenture trusteeship activities.</a:t>
             </a:r>
           </a:p>
           <a:p>
             <a:pPr>
               <a:spcBef>
-                <a:spcPts val="1200"/>
-              </a:spcBef>
-              <a:spcAft>
-                <a:spcPts val="400"/>
-              </a:spcAft>
-              <a:defRPr sz="1100" b="1"/>
-            </a:pPr>
-            <a:r>
-              <a:t>Effective Date:</a:t>
-            </a:r>
-          </a:p>
-          <a:p>
-            <a:pPr>
-              <a:spcBef>
-                <a:spcPts val="400"/>
-              </a:spcBef>
-              <a:spcAft>
-                <a:spcPts val="600"/>
+                <a:spcPts val="0"/>
+              </a:spcBef>
+              <a:spcAft>
+                <a:spcPts val="200"/>
               </a:spcAft>
               <a:defRPr sz="1100"/>
             </a:pPr>
             <a:r>
-              <a:t>Not specified</a:t>
-            </a:r>
-          </a:p>
-          <a:p>
-            <a:pPr>
-              <a:spcBef>
-                <a:spcPts val="1200"/>
-              </a:spcBef>
-              <a:spcAft>
-                <a:spcPts val="400"/>
-              </a:spcAft>
-              <a:defRPr sz="1100" b="1"/>
-            </a:pPr>
-            <a:r>
-              <a:t>Gist of amendment:</a:t>
-            </a:r>
-          </a:p>
-          <a:p>
-            <a:pPr>
-              <a:spcBef>
-                <a:spcPts val="400"/>
-              </a:spcBef>
-              <a:spcAft>
-                <a:spcPts val="600"/>
-              </a:spcAft>
-              <a:defRPr sz="1100"/>
-            </a:pPr>
-            <a:r>
-              <a:t>BSE has issued this circular and Issued a circular introducing and modifying the application of SEBI regulations for Resolution Plans approved under Section 54L of the Insolvency and Bankruptcy Code, 2016 in Pre-Packaged Insolvency Resolution Process (PPIRP).</a:t>
-            </a:r>
-          </a:p>
-          <a:p>
-            <a:pPr>
-              <a:spcBef>
-                <a:spcPts val="1200"/>
-              </a:spcBef>
-              <a:spcAft>
-                <a:spcPts val="400"/>
-              </a:spcAft>
-              <a:defRPr sz="1100" b="1"/>
-            </a:pPr>
-            <a:r>
-              <a:t>Submission of disclosures:</a:t>
-            </a:r>
-          </a:p>
-          <a:p>
-            <a:pPr>
-              <a:spcBef>
-                <a:spcPts val="400"/>
-              </a:spcBef>
-              <a:spcAft>
-                <a:spcPts val="600"/>
-              </a:spcAft>
-              <a:defRPr sz="1100"/>
-            </a:pPr>
-            <a:r>
-              <a:t>Listing Centre - Listing Compliance department at BSE Limited</a:t>
-            </a:r>
-          </a:p>
-          <a:p>
-            <a:pPr>
-              <a:spcBef>
-                <a:spcPts val="400"/>
-              </a:spcBef>
-              <a:spcAft>
-                <a:spcPts val="600"/>
-              </a:spcAft>
-              <a:defRPr sz="1100"/>
-            </a:pPr>
-            <a:r>
-              <a:t>Resolution Plans approved under Section 54L of the IBC under PPIRP framework will not be eligible for exemptions available under various SEBI Regulations.</a:t>
-            </a:r>
-          </a:p>
-          <a:p>
-            <a:pPr>
-              <a:spcBef>
-                <a:spcPts val="0"/>
-              </a:spcBef>
-              <a:spcAft>
-                <a:spcPts val="200"/>
-              </a:spcAft>
-              <a:defRPr sz="1100"/>
-            </a:pPr>
-            <a:r>
-              <a:t>- Listed entities undergoing PPIRP shall comply with all applicable procedural and regulatory requirements prescribed under relevant SEBI Regulations.</a:t>
-            </a:r>
-          </a:p>
-          <a:p>
-            <a:pPr>
-              <a:spcBef>
-                <a:spcPts val="0"/>
-              </a:spcBef>
-              <a:spcAft>
-                <a:spcPts val="200"/>
-              </a:spcAft>
-              <a:defRPr sz="1100"/>
-            </a:pPr>
-            <a:r>
-              <a:t>- Submissions should be made to the Listing Compliance department at BSE Limited.</a:t>
-            </a:r>
-          </a:p>
-          <a:p>
-            <a:pPr>
-              <a:spcBef>
-                <a:spcPts val="0"/>
-              </a:spcBef>
-              <a:spcAft>
-                <a:spcPts val="200"/>
-              </a:spcAft>
-              <a:defRPr sz="1100"/>
-            </a:pPr>
-            <a:r>
-              <a:t>- No alternative submission routes are specified, please contact the Listing Compliance department for unlisted fiduciaries or alternative paths.</a:t>
-            </a:r>
-          </a:p>
-          <a:p>
-            <a:pPr>
-              <a:spcBef>
-                <a:spcPts val="0"/>
-              </a:spcBef>
-              <a:spcAft>
-                <a:spcPts val="200"/>
-              </a:spcAft>
-              <a:defRPr sz="1100"/>
-            </a:pPr>
-            <a:r>
-              <a:t>- Previous exemptions for Resolution Plans approved under Section 31 of the IBC no longer apply to PPIRP.</a:t>
+              <a:t>- SEBI invites suggestions from the public, market participants, and stakeholders on the existing regulatory framework governing Debenture Trustees, including proposals for simplification, rationalisation, updates, enhancing roles, responsibilities, and ease of compliance — all submissions are to be made by July 15, 2026.</a:t>
             </a:r>
           </a:p>
         </p:txBody>
@@ -10047,8 +11269,8 @@
         </p:nvSpPr>
         <p:spPr>
           <a:xfrm>
-            <a:off x="457200" y="7662672"/>
-            <a:ext cx="6583680" cy="1801368"/>
+            <a:off x="457200" y="4672583"/>
+            <a:ext cx="6583680" cy="2249424"/>
           </a:xfrm>
           <a:prstGeom prst="rect">
             <a:avLst/>
@@ -10073,63 +11295,183 @@
                 </a:solidFill>
                 <a:hlinkClick r:id="rId4"/>
               </a:rPr>
-              <a:t>Frequently Asked Questions (FAQs) on the submission of the Quarterly Integrated Filing – Governance</a:t>
+              <a:t>SEBI Proposes Common Advertisement Code for Specified Regulated Entities</a:t>
             </a:r>
           </a:p>
           <a:p>
             <a:pPr>
               <a:spcBef>
-                <a:spcPts val="1200"/>
-              </a:spcBef>
-              <a:spcAft>
-                <a:spcPts val="400"/>
-              </a:spcAft>
-              <a:defRPr sz="1100" b="1"/>
-            </a:pPr>
-            <a:r>
-              <a:t>Date of Circular:</a:t>
+                <a:spcPts val="0"/>
+              </a:spcBef>
+              <a:spcAft>
+                <a:spcPts val="200"/>
+              </a:spcAft>
+              <a:defRPr sz="1100"/>
+            </a:pPr>
+            <a:r>
+              <a:t>- The press release issued states that SEBI has proposed a unified Common Advertisement Code (CAC) for various regulated entities, replacing the existing fragmented frameworks. This move aims to reduce regulatory complexity and compliance burden, ensuring a harmonized framework across entities.</a:t>
             </a:r>
           </a:p>
           <a:p>
             <a:pPr>
               <a:spcBef>
-                <a:spcPts val="400"/>
-              </a:spcBef>
+                <a:spcPts val="0"/>
+              </a:spcBef>
+              <a:spcAft>
+                <a:spcPts val="200"/>
+              </a:spcAft>
+              <a:defRPr sz="1100"/>
+            </a:pPr>
+            <a:r>
+              <a:t>- The CAC will permit post-issuance reporting instead of mandatory prior approval for advertisements. Additionally, the use of celebrities for brand promotion is proposed to be allowed, subject to prescribed conditions.</a:t>
+            </a:r>
+          </a:p>
+          <a:p>
+            <a:pPr>
+              <a:spcBef>
+                <a:spcPts val="0"/>
+              </a:spcBef>
+              <a:spcAft>
+                <a:spcPts val="200"/>
+              </a:spcAft>
+              <a:defRPr sz="1100"/>
+            </a:pPr>
+            <a:r>
+              <a:t>- SEBI has also suggested the recognition of ratings and rankings assigned by a Past Risk and Return Verification Agency (PaRRVA), enabling regulated entities to promote transparency while ensuring adequate safeguards. The final date for public comments on this proposal is July 14, 2026.</a:t>
+            </a:r>
+          </a:p>
+        </p:txBody>
+      </p:sp>
+      <p:sp>
+        <p:nvSpPr>
+          <p:cNvPr id="19" name="TextBox 18"/>
+          <p:cNvSpPr txBox="1"/>
+          <p:nvPr/>
+        </p:nvSpPr>
+        <p:spPr>
+          <a:xfrm>
+            <a:off x="457200" y="7059167"/>
+            <a:ext cx="6583680" cy="1591056"/>
+          </a:xfrm>
+          <a:prstGeom prst="rect">
+            <a:avLst/>
+          </a:prstGeom>
+          <a:noFill/>
+        </p:spPr>
+        <p:txBody>
+          <a:bodyPr wrap="square">
+            <a:spAutoFit/>
+          </a:bodyPr>
+          <a:lstStyle/>
+          <a:p>
+            <a:pPr>
               <a:spcAft>
                 <a:spcPts val="600"/>
               </a:spcAft>
+            </a:pPr>
+            <a:r>
+              <a:rPr b="1" sz="1200" u="sng">
+                <a:solidFill>
+                  <a:srgbClr val="0066CC"/>
+                </a:solidFill>
+                <a:hlinkClick r:id="rId5"/>
+              </a:rPr>
+              <a:t>Launch of Securities Market TechSprint at Global Fintech Fest 2026 (GFF ’26)</a:t>
+            </a:r>
+          </a:p>
+          <a:p>
+            <a:pPr>
+              <a:spcBef>
+                <a:spcPts val="0"/>
+              </a:spcBef>
+              <a:spcAft>
+                <a:spcPts val="200"/>
+              </a:spcAft>
               <a:defRPr sz="1100"/>
             </a:pPr>
             <a:r>
-              <a:t>2026-06-12</a:t>
+              <a:t>- The press release issued states that SEBI has launched the Securities Market TechSprint as part of Global Fintech Fest 2026 (GFF'26).</a:t>
             </a:r>
           </a:p>
           <a:p>
             <a:pPr>
               <a:spcBef>
-                <a:spcPts val="1200"/>
-              </a:spcBef>
-              <a:spcAft>
-                <a:spcPts val="400"/>
-              </a:spcAft>
-              <a:defRPr sz="1100" b="1"/>
-            </a:pPr>
-            <a:r>
-              <a:t>Effective Date:</a:t>
+                <a:spcPts val="0"/>
+              </a:spcBef>
+              <a:spcAft>
+                <a:spcPts val="200"/>
+              </a:spcAft>
+              <a:defRPr sz="1100"/>
+            </a:pPr>
+            <a:r>
+              <a:t>- This initiative invites innovators to develop digital solutions addressing challenges within securities market, focusing on empowering retail investors and enhancing transparency, efficiency, compliance, and accessibility.</a:t>
             </a:r>
           </a:p>
           <a:p>
             <a:pPr>
               <a:spcBef>
-                <a:spcPts val="400"/>
-              </a:spcBef>
+                <a:spcPts val="0"/>
+              </a:spcBef>
+              <a:spcAft>
+                <a:spcPts val="200"/>
+              </a:spcAft>
+              <a:defRPr sz="1100"/>
+            </a:pPr>
+            <a:r>
+              <a:t>- The TechSprint offers participants a chance to showcase groundbreaking solutions at GFF, win cash prizes, and be considered for mentorship through SEBI Innovation Sandbox.</a:t>
+            </a:r>
+          </a:p>
+        </p:txBody>
+      </p:sp>
+      <p:sp>
+        <p:nvSpPr>
+          <p:cNvPr id="20" name="TextBox 19"/>
+          <p:cNvSpPr txBox="1"/>
+          <p:nvPr/>
+        </p:nvSpPr>
+        <p:spPr>
+          <a:xfrm>
+            <a:off x="457200" y="8787384"/>
+            <a:ext cx="6583680" cy="676656"/>
+          </a:xfrm>
+          <a:prstGeom prst="rect">
+            <a:avLst/>
+          </a:prstGeom>
+          <a:noFill/>
+        </p:spPr>
+        <p:txBody>
+          <a:bodyPr wrap="square">
+            <a:spAutoFit/>
+          </a:bodyPr>
+          <a:lstStyle/>
+          <a:p>
+            <a:pPr>
               <a:spcAft>
                 <a:spcPts val="600"/>
               </a:spcAft>
+            </a:pPr>
+            <a:r>
+              <a:rPr b="1" sz="1200" u="sng">
+                <a:solidFill>
+                  <a:srgbClr val="0066CC"/>
+                </a:solidFill>
+                <a:hlinkClick r:id="rId6"/>
+              </a:rPr>
+              <a:t>Key decisions taken in the SEBI Board Meeting dated 19th June, 2026</a:t>
+            </a:r>
+          </a:p>
+          <a:p>
+            <a:pPr>
+              <a:spcBef>
+                <a:spcPts val="0"/>
+              </a:spcBef>
+              <a:spcAft>
+                <a:spcPts val="200"/>
+              </a:spcAft>
               <a:defRPr sz="1100"/>
             </a:pPr>
             <a:r>
-              <a:t>Not specified</a:t>
+              <a:t>- The press release issued states that SEBI has simplified and standardised the framework for transmission of securities to legal heirs/claimants of deceased investors.</a:t>
             </a:r>
           </a:p>
         </p:txBody>
@@ -10503,7 +11845,7 @@
                 <a:cs typeface="Montserrat Classic Bold"/>
                 <a:sym typeface="Montserrat Classic Bold"/>
               </a:rPr>
-              <a:t>Page 6 of 12</a:t>
+              <a:t>Page 6 of 13</a:t>
             </a:r>
           </a:p>
           <a:p>
@@ -10940,7 +12282,7 @@
         <p:spPr>
           <a:xfrm>
             <a:off x="457200" y="1828800"/>
-            <a:ext cx="6583680" cy="3227832"/>
+            <a:ext cx="6583680" cy="1078992"/>
           </a:xfrm>
           <a:prstGeom prst="rect">
             <a:avLst/>
@@ -10955,113 +12297,29 @@
           <a:p>
             <a:pPr>
               <a:spcBef>
-                <a:spcPts val="1200"/>
-              </a:spcBef>
-              <a:spcAft>
-                <a:spcPts val="400"/>
-              </a:spcAft>
-              <a:defRPr sz="1100" b="1"/>
-            </a:pPr>
-            <a:r>
-              <a:t>Gist of amendment:</a:t>
+                <a:spcPts val="0"/>
+              </a:spcBef>
+              <a:spcAft>
+                <a:spcPts val="200"/>
+              </a:spcAft>
+              <a:defRPr sz="1100"/>
+            </a:pPr>
+            <a:r>
+              <a:t>- Key changes include: introduction of Quick Transmission Processing (QTP) for small-value claims, doubling limits for simplified documentation, removal of PAN requirement, doing away with Probate of Will, allowing combined affidavit-cum-NOC, acceptance of death certificate with QR Code, and addition of modes for verification from overseas banks.</a:t>
             </a:r>
           </a:p>
           <a:p>
             <a:pPr>
               <a:spcBef>
-                <a:spcPts val="400"/>
-              </a:spcBef>
-              <a:spcAft>
-                <a:spcPts val="600"/>
+                <a:spcPts val="0"/>
+              </a:spcBef>
+              <a:spcAft>
+                <a:spcPts val="200"/>
               </a:spcAft>
               <a:defRPr sz="1100"/>
             </a:pPr>
             <a:r>
-              <a:t>BSE has issued this circular and Issued a circular titled "Frequently Asked Questions (FAQs) on the submission of the Quarterly Integrated Filing  -  Governance." This circular modifies the submission process for the Integrated Filing  -  Governance, formerly known as Corporate Governance Report.</a:t>
-            </a:r>
-          </a:p>
-          <a:p>
-            <a:pPr>
-              <a:spcBef>
-                <a:spcPts val="1200"/>
-              </a:spcBef>
-              <a:spcAft>
-                <a:spcPts val="400"/>
-              </a:spcAft>
-              <a:defRPr sz="1100" b="1"/>
-            </a:pPr>
-            <a:r>
-              <a:t>Submission of disclosures:</a:t>
-            </a:r>
-          </a:p>
-          <a:p>
-            <a:pPr>
-              <a:spcBef>
-                <a:spcPts val="400"/>
-              </a:spcBef>
-              <a:spcAft>
-                <a:spcPts val="600"/>
-              </a:spcAft>
-              <a:defRPr sz="1100"/>
-            </a:pPr>
-            <a:r>
-              <a:t>Listing Centre - To submit the Quarterly Integrated Filing  -  Governance, refer to the listed entities' regular filing workflow.</a:t>
-            </a:r>
-          </a:p>
-          <a:p>
-            <a:pPr>
-              <a:spcBef>
-                <a:spcPts val="400"/>
-              </a:spcBef>
-              <a:spcAft>
-                <a:spcPts val="600"/>
-              </a:spcAft>
-              <a:defRPr sz="1100"/>
-            </a:pPr>
-            <a:r>
-              <a:t>The submissions must be in XBRL mode only. No PDF files are accepted.</a:t>
-            </a:r>
-          </a:p>
-          <a:p>
-            <a:pPr>
-              <a:spcBef>
-                <a:spcPts val="0"/>
-              </a:spcBef>
-              <a:spcAft>
-                <a:spcPts val="200"/>
-              </a:spcAft>
-              <a:defRPr sz="1100"/>
-            </a:pPr>
-            <a:r>
-              <a:t>- If any unlisted fiduciaries have queries or issues, they can contact Listing Compliance and Operations through email at [email protected]</a:t>
-            </a:r>
-          </a:p>
-          <a:p>
-            <a:pPr>
-              <a:spcBef>
-                <a:spcPts val="0"/>
-              </a:spcBef>
-              <a:spcAft>
-                <a:spcPts val="200"/>
-              </a:spcAft>
-              <a:defRPr sz="1100"/>
-            </a:pPr>
-            <a:r>
-              <a:t>- The legacy paths for Corporate Governance Report submission are now discontinued.</a:t>
-            </a:r>
-          </a:p>
-          <a:p>
-            <a:pPr>
-              <a:spcBef>
-                <a:spcPts val="0"/>
-              </a:spcBef>
-              <a:spcAft>
-                <a:spcPts val="200"/>
-              </a:spcAft>
-              <a:defRPr sz="1100"/>
-            </a:pPr>
-            <a:r>
-              <a:t>- Submissions via alternative routes (other than the regular filing workflow) are considered invalid.</a:t>
+              <a:t>- These measures are expected to facilitate easier and faster transmission of securities and reduce costs and procedural hardship for claimants.</a:t>
             </a:r>
           </a:p>
         </p:txBody>
@@ -11074,8 +12332,8 @@
         </p:nvSpPr>
         <p:spPr>
           <a:xfrm>
-            <a:off x="457200" y="5193792"/>
-            <a:ext cx="6583680" cy="457200"/>
+            <a:off x="457200" y="3044952"/>
+            <a:ext cx="6583680" cy="1755648"/>
           </a:xfrm>
           <a:prstGeom prst="rect">
             <a:avLst/>
@@ -11083,41 +12341,6 @@
           <a:noFill/>
         </p:spPr>
         <p:txBody>
-          <a:bodyPr wrap="none">
-            <a:spAutoFit/>
-          </a:bodyPr>
-          <a:lstStyle/>
-          <a:p>
-            <a:pPr>
-              <a:defRPr b="1" sz="1600">
-                <a:solidFill>
-                  <a:srgbClr val="003399"/>
-                </a:solidFill>
-              </a:defRPr>
-            </a:pPr>
-            <a:r>
-              <a:t>➤ PRESS RELEASE</a:t>
-            </a:r>
-          </a:p>
-        </p:txBody>
-      </p:sp>
-      <p:sp>
-        <p:nvSpPr>
-          <p:cNvPr id="18" name="TextBox 17"/>
-          <p:cNvSpPr txBox="1"/>
-          <p:nvPr/>
-        </p:nvSpPr>
-        <p:spPr>
-          <a:xfrm>
-            <a:off x="457200" y="5650992"/>
-            <a:ext cx="6583680" cy="2249424"/>
-          </a:xfrm>
-          <a:prstGeom prst="rect">
-            <a:avLst/>
-          </a:prstGeom>
-          <a:noFill/>
-        </p:spPr>
-        <p:txBody>
           <a:bodyPr wrap="square">
             <a:spAutoFit/>
           </a:bodyPr>
@@ -11135,7 +12358,7 @@
                 </a:solidFill>
                 <a:hlinkClick r:id="rId3"/>
               </a:rPr>
-              <a:t>Constitution of an Expert Working Group on review of extant regulatory framework applicable for Debenture Trusteeship activities and other incidental matters</a:t>
+              <a:t>Transaction in Securities of Unlisted Public Limited Companies on various Platforms</a:t>
             </a:r>
           </a:p>
           <a:p>
@@ -11149,7 +12372,7 @@
               <a:defRPr sz="1100"/>
             </a:pPr>
             <a:r>
-              <a:t>- The press release issued states that SEBI has constituted an Expert Working Group to review the regulatory framework applicable for Debenture Trusteeship activities, aiming to align it with changing market dynamics.</a:t>
+              <a:t>- The press release issued states that SEBI has warned against conducting transactions in unlisted securities on unauthorized electronic platforms or sharing sensitive personal details, as these platforms are neither authorized nor recognized by SEBI.</a:t>
             </a:r>
           </a:p>
           <a:p>
@@ -11163,7 +12386,7 @@
               <a:defRPr sz="1100"/>
             </a:pPr>
             <a:r>
-              <a:t>- The Working Group will examine representations and suggestions from market participants, recommend measures to strengthen Debenture Trustee roles, review net-worth requirements, and consider other relevant matters related to debenture trusteeship activities.</a:t>
+              <a:t>- SEBI reiterates that only recognized stock exchanges are authorized to provide a platform for fund raising and trading in securities.</a:t>
             </a:r>
           </a:p>
           <a:p>
@@ -11177,74 +12400,7 @@
               <a:defRPr sz="1100"/>
             </a:pPr>
             <a:r>
-              <a:t>- SEBI invites suggestions from the public, market participants, and stakeholders on the existing regulatory framework governing Debenture Trustees, including proposals for simplification, rationalisation, updates, enhancing roles, responsibilities, and ease of compliance — all submissions are to be made by July 15, 2026.</a:t>
-            </a:r>
-          </a:p>
-        </p:txBody>
-      </p:sp>
-      <p:sp>
-        <p:nvSpPr>
-          <p:cNvPr id="19" name="TextBox 18"/>
-          <p:cNvSpPr txBox="1"/>
-          <p:nvPr/>
-        </p:nvSpPr>
-        <p:spPr>
-          <a:xfrm>
-            <a:off x="457200" y="8037575"/>
-            <a:ext cx="6583680" cy="1545336"/>
-          </a:xfrm>
-          <a:prstGeom prst="rect">
-            <a:avLst/>
-          </a:prstGeom>
-          <a:noFill/>
-        </p:spPr>
-        <p:txBody>
-          <a:bodyPr wrap="square">
-            <a:spAutoFit/>
-          </a:bodyPr>
-          <a:lstStyle/>
-          <a:p>
-            <a:pPr>
-              <a:spcAft>
-                <a:spcPts val="600"/>
-              </a:spcAft>
-            </a:pPr>
-            <a:r>
-              <a:rPr b="1" sz="1200" u="sng">
-                <a:solidFill>
-                  <a:srgbClr val="0066CC"/>
-                </a:solidFill>
-                <a:hlinkClick r:id="rId4"/>
-              </a:rPr>
-              <a:t>SEBI Proposes Common Advertisement Code for Specified Regulated Entities</a:t>
-            </a:r>
-          </a:p>
-          <a:p>
-            <a:pPr>
-              <a:spcBef>
-                <a:spcPts val="0"/>
-              </a:spcBef>
-              <a:spcAft>
-                <a:spcPts val="200"/>
-              </a:spcAft>
-              <a:defRPr sz="1100"/>
-            </a:pPr>
-            <a:r>
-              <a:t>- The press release issued states that SEBI has proposed a unified Common Advertisement Code (CAC) for various regulated entities, replacing the existing fragmented frameworks. This move aims to reduce regulatory complexity and compliance burden, ensuring a harmonized framework across entities.</a:t>
-            </a:r>
-          </a:p>
-          <a:p>
-            <a:pPr>
-              <a:spcBef>
-                <a:spcPts val="0"/>
-              </a:spcBef>
-              <a:spcAft>
-                <a:spcPts val="200"/>
-              </a:spcAft>
-              <a:defRPr sz="1100"/>
-            </a:pPr>
-            <a:r>
-              <a:t>- The CAC will permit post-issuance reporting instead of mandatory prior approval for advertisements. Additionally, the use of celebrities for brand promotion is proposed to be allowed, subject to prescribed conditions.</a:t>
+              <a:t>- Investors are informed that no investor protection benefits or grievance redressal mechanisms will be available to them in case of disputes related to participation on such unauthorized platforms.</a:t>
             </a:r>
           </a:p>
         </p:txBody>
@@ -11660,7 +12816,7 @@
                 <a:cs typeface="Montserrat Classic Bold"/>
                 <a:sym typeface="Montserrat Classic Bold"/>
               </a:rPr>
-              <a:t>Page 7 of 12</a:t>
+              <a:t>Page 7 of 13</a:t>
             </a:r>
           </a:p>
         </p:txBody>
@@ -12077,286 +13233,6 @@
         <p:spPr>
           <a:xfrm>
             <a:off x="457200" y="1828800"/>
-            <a:ext cx="6583680" cy="704088"/>
-          </a:xfrm>
-          <a:prstGeom prst="rect">
-            <a:avLst/>
-          </a:prstGeom>
-          <a:noFill/>
-        </p:spPr>
-        <p:txBody>
-          <a:bodyPr wrap="square">
-            <a:spAutoFit/>
-          </a:bodyPr>
-          <a:lstStyle/>
-          <a:p>
-            <a:pPr>
-              <a:spcBef>
-                <a:spcPts val="0"/>
-              </a:spcBef>
-              <a:spcAft>
-                <a:spcPts val="200"/>
-              </a:spcAft>
-              <a:defRPr sz="1100"/>
-            </a:pPr>
-            <a:r>
-              <a:t>- SEBI has also suggested the recognition of ratings and rankings assigned by a Past Risk and Return Verification Agency (PaRRVA), enabling regulated entities to promote transparency while ensuring adequate safeguards. The final date for public comments on this proposal is July 14, 2026.</a:t>
-            </a:r>
-          </a:p>
-        </p:txBody>
-      </p:sp>
-      <p:sp>
-        <p:nvSpPr>
-          <p:cNvPr id="17" name="TextBox 16"/>
-          <p:cNvSpPr txBox="1"/>
-          <p:nvPr/>
-        </p:nvSpPr>
-        <p:spPr>
-          <a:xfrm>
-            <a:off x="457200" y="2670048"/>
-            <a:ext cx="6583680" cy="1591056"/>
-          </a:xfrm>
-          <a:prstGeom prst="rect">
-            <a:avLst/>
-          </a:prstGeom>
-          <a:noFill/>
-        </p:spPr>
-        <p:txBody>
-          <a:bodyPr wrap="square">
-            <a:spAutoFit/>
-          </a:bodyPr>
-          <a:lstStyle/>
-          <a:p>
-            <a:pPr>
-              <a:spcAft>
-                <a:spcPts val="600"/>
-              </a:spcAft>
-            </a:pPr>
-            <a:r>
-              <a:rPr b="1" sz="1200" u="sng">
-                <a:solidFill>
-                  <a:srgbClr val="0066CC"/>
-                </a:solidFill>
-                <a:hlinkClick r:id="rId3"/>
-              </a:rPr>
-              <a:t>Launch of Securities Market TechSprint at Global Fintech Fest 2026 (GFF ’26)</a:t>
-            </a:r>
-          </a:p>
-          <a:p>
-            <a:pPr>
-              <a:spcBef>
-                <a:spcPts val="0"/>
-              </a:spcBef>
-              <a:spcAft>
-                <a:spcPts val="200"/>
-              </a:spcAft>
-              <a:defRPr sz="1100"/>
-            </a:pPr>
-            <a:r>
-              <a:t>- The press release issued states that SEBI has launched the Securities Market TechSprint as part of Global Fintech Fest 2026 (GFF'26).</a:t>
-            </a:r>
-          </a:p>
-          <a:p>
-            <a:pPr>
-              <a:spcBef>
-                <a:spcPts val="0"/>
-              </a:spcBef>
-              <a:spcAft>
-                <a:spcPts val="200"/>
-              </a:spcAft>
-              <a:defRPr sz="1100"/>
-            </a:pPr>
-            <a:r>
-              <a:t>- This initiative invites innovators to develop digital solutions addressing challenges within securities market, focusing on empowering retail investors and enhancing transparency, efficiency, compliance, and accessibility.</a:t>
-            </a:r>
-          </a:p>
-          <a:p>
-            <a:pPr>
-              <a:spcBef>
-                <a:spcPts val="0"/>
-              </a:spcBef>
-              <a:spcAft>
-                <a:spcPts val="200"/>
-              </a:spcAft>
-              <a:defRPr sz="1100"/>
-            </a:pPr>
-            <a:r>
-              <a:t>- The TechSprint offers participants a chance to showcase groundbreaking solutions at GFF, win cash prizes, and be considered for mentorship through SEBI Innovation Sandbox.</a:t>
-            </a:r>
-          </a:p>
-        </p:txBody>
-      </p:sp>
-      <p:sp>
-        <p:nvSpPr>
-          <p:cNvPr id="18" name="TextBox 17"/>
-          <p:cNvSpPr txBox="1"/>
-          <p:nvPr/>
-        </p:nvSpPr>
-        <p:spPr>
-          <a:xfrm>
-            <a:off x="457200" y="4398264"/>
-            <a:ext cx="6583680" cy="1755648"/>
-          </a:xfrm>
-          <a:prstGeom prst="rect">
-            <a:avLst/>
-          </a:prstGeom>
-          <a:noFill/>
-        </p:spPr>
-        <p:txBody>
-          <a:bodyPr wrap="square">
-            <a:spAutoFit/>
-          </a:bodyPr>
-          <a:lstStyle/>
-          <a:p>
-            <a:pPr>
-              <a:spcAft>
-                <a:spcPts val="600"/>
-              </a:spcAft>
-            </a:pPr>
-            <a:r>
-              <a:rPr b="1" sz="1200" u="sng">
-                <a:solidFill>
-                  <a:srgbClr val="0066CC"/>
-                </a:solidFill>
-                <a:hlinkClick r:id="rId4"/>
-              </a:rPr>
-              <a:t>Key decisions taken in the SEBI Board Meeting dated 19th June, 2026</a:t>
-            </a:r>
-          </a:p>
-          <a:p>
-            <a:pPr>
-              <a:spcBef>
-                <a:spcPts val="0"/>
-              </a:spcBef>
-              <a:spcAft>
-                <a:spcPts val="200"/>
-              </a:spcAft>
-              <a:defRPr sz="1100"/>
-            </a:pPr>
-            <a:r>
-              <a:t>- The press release issued states that SEBI has simplified and standardised the framework for transmission of securities to legal heirs/claimants of deceased investors.</a:t>
-            </a:r>
-          </a:p>
-          <a:p>
-            <a:pPr>
-              <a:spcBef>
-                <a:spcPts val="0"/>
-              </a:spcBef>
-              <a:spcAft>
-                <a:spcPts val="200"/>
-              </a:spcAft>
-              <a:defRPr sz="1100"/>
-            </a:pPr>
-            <a:r>
-              <a:t>- Key changes include: introduction of Quick Transmission Processing (QTP) for small-value claims, doubling limits for simplified documentation, removal of PAN requirement, doing away with Probate of Will, allowing combined affidavit-cum-NOC, acceptance of death certificate with QR Code, and addition of modes for verification from overseas banks.</a:t>
-            </a:r>
-          </a:p>
-          <a:p>
-            <a:pPr>
-              <a:spcBef>
-                <a:spcPts val="0"/>
-              </a:spcBef>
-              <a:spcAft>
-                <a:spcPts val="200"/>
-              </a:spcAft>
-              <a:defRPr sz="1100"/>
-            </a:pPr>
-            <a:r>
-              <a:t>- These measures are expected to facilitate easier and faster transmission of securities and reduce costs and procedural hardship for claimants.</a:t>
-            </a:r>
-          </a:p>
-        </p:txBody>
-      </p:sp>
-      <p:sp>
-        <p:nvSpPr>
-          <p:cNvPr id="19" name="TextBox 18"/>
-          <p:cNvSpPr txBox="1"/>
-          <p:nvPr/>
-        </p:nvSpPr>
-        <p:spPr>
-          <a:xfrm>
-            <a:off x="457200" y="6291071"/>
-            <a:ext cx="6583680" cy="1755648"/>
-          </a:xfrm>
-          <a:prstGeom prst="rect">
-            <a:avLst/>
-          </a:prstGeom>
-          <a:noFill/>
-        </p:spPr>
-        <p:txBody>
-          <a:bodyPr wrap="square">
-            <a:spAutoFit/>
-          </a:bodyPr>
-          <a:lstStyle/>
-          <a:p>
-            <a:pPr>
-              <a:spcAft>
-                <a:spcPts val="600"/>
-              </a:spcAft>
-            </a:pPr>
-            <a:r>
-              <a:rPr b="1" sz="1200" u="sng">
-                <a:solidFill>
-                  <a:srgbClr val="0066CC"/>
-                </a:solidFill>
-                <a:hlinkClick r:id="rId5"/>
-              </a:rPr>
-              <a:t>Transaction in Securities of Unlisted Public Limited Companies on various Platforms</a:t>
-            </a:r>
-          </a:p>
-          <a:p>
-            <a:pPr>
-              <a:spcBef>
-                <a:spcPts val="0"/>
-              </a:spcBef>
-              <a:spcAft>
-                <a:spcPts val="200"/>
-              </a:spcAft>
-              <a:defRPr sz="1100"/>
-            </a:pPr>
-            <a:r>
-              <a:t>- The press release issued states that SEBI has warned against conducting transactions in unlisted securities on unauthorized electronic platforms or sharing sensitive personal details, as these platforms are neither authorized nor recognized by SEBI.</a:t>
-            </a:r>
-          </a:p>
-          <a:p>
-            <a:pPr>
-              <a:spcBef>
-                <a:spcPts val="0"/>
-              </a:spcBef>
-              <a:spcAft>
-                <a:spcPts val="200"/>
-              </a:spcAft>
-              <a:defRPr sz="1100"/>
-            </a:pPr>
-            <a:r>
-              <a:t>- SEBI reiterates that only recognized stock exchanges are authorized to provide a platform for fund raising and trading in securities.</a:t>
-            </a:r>
-          </a:p>
-          <a:p>
-            <a:pPr>
-              <a:spcBef>
-                <a:spcPts val="0"/>
-              </a:spcBef>
-              <a:spcAft>
-                <a:spcPts val="200"/>
-              </a:spcAft>
-              <a:defRPr sz="1100"/>
-            </a:pPr>
-            <a:r>
-              <a:t>- Investors are informed that no investor protection benefits or grievance redressal mechanisms will be available to them in case of disputes related to participation on such unauthorized platforms.</a:t>
-            </a:r>
-          </a:p>
-        </p:txBody>
-      </p:sp>
-      <p:sp>
-        <p:nvSpPr>
-          <p:cNvPr id="20" name="TextBox 19"/>
-          <p:cNvSpPr txBox="1"/>
-          <p:nvPr/>
-        </p:nvSpPr>
-        <p:spPr>
-          <a:xfrm>
-            <a:off x="457200" y="8183879"/>
             <a:ext cx="6583680" cy="457200"/>
           </a:xfrm>
           <a:prstGeom prst="rect">
@@ -12385,14 +13261,14 @@
       </p:sp>
       <p:sp>
         <p:nvSpPr>
-          <p:cNvPr id="21" name="TextBox 20"/>
+          <p:cNvPr id="17" name="TextBox 16"/>
           <p:cNvSpPr txBox="1"/>
           <p:nvPr/>
         </p:nvSpPr>
         <p:spPr>
           <a:xfrm>
-            <a:off x="457200" y="8641080"/>
-            <a:ext cx="6583680" cy="576071"/>
+            <a:off x="457200" y="2286000"/>
+            <a:ext cx="6583680" cy="5513831"/>
           </a:xfrm>
           <a:prstGeom prst="rect">
             <a:avLst/>
@@ -12415,7 +13291,7 @@
                 <a:solidFill>
                   <a:srgbClr val="0066CC"/>
                 </a:solidFill>
-                <a:hlinkClick r:id="rId6"/>
+                <a:hlinkClick r:id="rId3"/>
               </a:rPr>
               <a:t>Consultation Paper on Common Advertisement Code for Specified SEBI Regulated Entities</a:t>
             </a:r>
@@ -12432,6 +13308,157 @@
             </a:pPr>
             <a:r>
               <a:t>Title: Proposal for a Unified Advertisement Code for Financial Entities</a:t>
+            </a:r>
+          </a:p>
+          <a:p>
+            <a:pPr>
+              <a:spcBef>
+                <a:spcPts val="400"/>
+              </a:spcBef>
+              <a:spcAft>
+                <a:spcPts val="600"/>
+              </a:spcAft>
+              <a:defRPr sz="1100"/>
+            </a:pPr>
+            <a:r>
+              <a:t>The Securities and Exchange Board of India (SEBI) is considering a new advertisement code aimed at simplifying regulatory compliance, reducing operational inefficiencies, and promoting investor protection. Here are the key proposals:</a:t>
+            </a:r>
+          </a:p>
+          <a:p>
+            <a:pPr>
+              <a:spcBef>
+                <a:spcPts val="400"/>
+              </a:spcBef>
+              <a:spcAft>
+                <a:spcPts val="600"/>
+              </a:spcAft>
+              <a:defRPr sz="1100"/>
+            </a:pPr>
+            <a:r>
+              <a:t>1. Celebrity Endorsements: Permitting celebrity endorsement for brand/entity level, subject to certain conditions and appropriate disclaimers. The proposal aims to balance legitimate marketing objectives with investor protection. Celebrities would not be allowed to endorse specific products or services to avoid undue influence on investors' decisions.</a:t>
+            </a:r>
+          </a:p>
+          <a:p>
+            <a:pPr>
+              <a:spcBef>
+                <a:spcPts val="400"/>
+              </a:spcBef>
+              <a:spcAft>
+                <a:spcPts val="600"/>
+              </a:spcAft>
+              <a:defRPr sz="1100"/>
+            </a:pPr>
+            <a:r>
+              <a:t>2. Removal of Mandatory Prior Approval: Replacing the requirement for prior approval from exchanges and supervisory bodies with a post-issuance reporting model. This change is expected to streamline the advertisement process, reduce potential delays, and promote efficient business operations. However, celebrity endorsements would still require prior approval.</a:t>
+            </a:r>
+          </a:p>
+          <a:p>
+            <a:pPr>
+              <a:spcBef>
+                <a:spcPts val="400"/>
+              </a:spcBef>
+              <a:spcAft>
+                <a:spcPts val="600"/>
+              </a:spcAft>
+              <a:defRPr sz="1100"/>
+            </a:pPr>
+            <a:r>
+              <a:t>3. Use of Ratings/Rankings in Advertisements: Allowing specified regulated entities to use ratings/rankings assigned by Past Risk and Return Verification Agency (PaRRVA), provided these ratings/rankings meet certain conditions, such as transparency about the methodology used, clear explanations within the advertisement, and a statement that ratings/rankings are one of several factors to consider when deciding on a service.</a:t>
+            </a:r>
+          </a:p>
+          <a:p>
+            <a:pPr>
+              <a:spcBef>
+                <a:spcPts val="400"/>
+              </a:spcBef>
+              <a:spcAft>
+                <a:spcPts val="600"/>
+              </a:spcAft>
+              <a:defRPr sz="1100"/>
+            </a:pPr>
+            <a:r>
+              <a:t>4. Abbreviated Disclosures for Short-Format Messaging: Allowing abbreviated disclosures in short format messaging such as SMS, pop-ups, push notifications, etc., with a hyperlink to full details and disclaimers available on the official website of the regulated entity. This change recognizes the space/time constraints of these formats and aims to make disclosures more practical and user-friendly.</a:t>
+            </a:r>
+          </a:p>
+          <a:p>
+            <a:pPr>
+              <a:spcBef>
+                <a:spcPts val="400"/>
+              </a:spcBef>
+              <a:spcAft>
+                <a:spcPts val="600"/>
+              </a:spcAft>
+              <a:defRPr sz="1100"/>
+            </a:pPr>
+            <a:r>
+              <a:t>The proposed changes aim to improve ease of doing business, consolidate existing advertisement codes, enhance investor protection, ensure regulatory consistency, promote accountability through post-issuance reporting, and rationalize compliance requirements. The final decision will be made after considering feedback from stakeholders.</a:t>
+            </a:r>
+          </a:p>
+        </p:txBody>
+      </p:sp>
+      <p:sp>
+        <p:nvSpPr>
+          <p:cNvPr id="18" name="TextBox 17"/>
+          <p:cNvSpPr txBox="1"/>
+          <p:nvPr/>
+        </p:nvSpPr>
+        <p:spPr>
+          <a:xfrm>
+            <a:off x="457200" y="7936992"/>
+            <a:ext cx="6583680" cy="1627632"/>
+          </a:xfrm>
+          <a:prstGeom prst="rect">
+            <a:avLst/>
+          </a:prstGeom>
+          <a:noFill/>
+        </p:spPr>
+        <p:txBody>
+          <a:bodyPr wrap="square">
+            <a:spAutoFit/>
+          </a:bodyPr>
+          <a:lstStyle/>
+          <a:p>
+            <a:pPr>
+              <a:spcAft>
+                <a:spcPts val="600"/>
+              </a:spcAft>
+            </a:pPr>
+            <a:r>
+              <a:rPr b="1" sz="1200" u="sng">
+                <a:solidFill>
+                  <a:srgbClr val="0066CC"/>
+                </a:solidFill>
+                <a:hlinkClick r:id="rId4"/>
+              </a:rPr>
+              <a:t>Consultation Paper on Review of Margin Trading Facility (MTF) Framework</a:t>
+            </a:r>
+          </a:p>
+          <a:p>
+            <a:pPr>
+              <a:spcBef>
+                <a:spcPts val="400"/>
+              </a:spcBef>
+              <a:spcAft>
+                <a:spcPts val="600"/>
+              </a:spcAft>
+              <a:defRPr sz="1100"/>
+            </a:pPr>
+            <a:r>
+              <a:t>The document provides a proposal to review and modify the Margin Trading Facility (MTF) Framework in India, which is currently limited to Equity Shares and units of Equity ETFs that are classified as 'Group I security'. The changes aim to enhance the functionality, reduce the minimum net-worth threshold for eligibility, and introduce new disclosure requirements.</a:t>
+            </a:r>
+          </a:p>
+          <a:p>
+            <a:pPr>
+              <a:spcBef>
+                <a:spcPts val="1200"/>
+              </a:spcBef>
+              <a:spcAft>
+                <a:spcPts val="400"/>
+              </a:spcAft>
+              <a:defRPr sz="1100" b="1"/>
+            </a:pPr>
+            <a:r>
+              <a:t>Here's a summary of the proposed changes:</a:t>
             </a:r>
           </a:p>
         </p:txBody>
@@ -12852,7 +13879,7 @@
                 <a:cs typeface="Montserrat Classic Bold"/>
                 <a:sym typeface="Montserrat Classic Bold"/>
               </a:rPr>
-              <a:t>Page 8 of 12</a:t>
+              <a:t>Page 8 of 13</a:t>
             </a:r>
           </a:p>
         </p:txBody>
@@ -13269,7 +14296,7 @@
         <p:spPr>
           <a:xfrm>
             <a:off x="457200" y="1828800"/>
-            <a:ext cx="6583680" cy="4937760"/>
+            <a:ext cx="6583680" cy="4882896"/>
           </a:xfrm>
           <a:prstGeom prst="rect">
             <a:avLst/>
@@ -13292,7 +14319,7 @@
               <a:defRPr sz="1100"/>
             </a:pPr>
             <a:r>
-              <a:t>The Securities and Exchange Board of India (SEBI) is considering a new advertisement code aimed at simplifying regulatory compliance, reducing operational inefficiencies, and promoting investor protection. Here are the key proposals:</a:t>
+              <a:t>1. Increase in minimum net worth: Eligibility of Stock Brokers to offer MTF may be increased from Rs. 3.00 crore to Rs. 5 Crore.</a:t>
             </a:r>
           </a:p>
           <a:p>
@@ -13306,7 +14333,7 @@
               <a:defRPr sz="1100"/>
             </a:pPr>
             <a:r>
-              <a:t>1. Celebrity Endorsements: Permitting celebrity endorsement for brand/entity level, subject to certain conditions and appropriate disclaimers. The proposal aims to balance legitimate marketing objectives with investor protection. Celebrities would not be allowed to endorse specific products or services to avoid undue influence on investors' decisions.</a:t>
+              <a:t>2. Allowance for LLPs: Brokers in the form of Limited Liability Partnership (LLP) may also be allowed to offer MTF to their clients.</a:t>
             </a:r>
           </a:p>
           <a:p>
@@ -13320,7 +14347,7 @@
               <a:defRPr sz="1100"/>
             </a:pPr>
             <a:r>
-              <a:t>2. Removal of Mandatory Prior Approval: Replacing the requirement for prior approval from exchanges and supervisory bodies with a post-issuance reporting model. This change is expected to streamline the advertisement process, reduce potential delays, and promote efficient business operations. However, celebrity endorsements would still require prior approval.</a:t>
+              <a:t>3. Disclosure requirements: Stock brokers are required to report MTF details on a gross exposure basis to Stock Exchanges on T+1 day, including the name of the client, category of holding, clients' Permanent Account Number (PAN), and the names of lenders and amounts borrowed.</a:t>
             </a:r>
           </a:p>
           <a:p>
@@ -13334,7 +14361,7 @@
               <a:defRPr sz="1100"/>
             </a:pPr>
             <a:r>
-              <a:t>3. Use of Ratings/Rankings in Advertisements: Allowing specified regulated entities to use ratings/rankings assigned by Past Risk and Return Verification Agency (PaRRVA), provided these ratings/rankings meet certain conditions, such as transparency about the methodology used, clear explanations within the advertisement, and a statement that ratings/rankings are one of several factors to consider when deciding on a service.</a:t>
+              <a:t>4. Transfer of entries: Stock brokers should maintain separate ledgers for funds and securities of clients availing margin trading facility. Fungibility of unencumbered funds or securities between the normal ledger and the MTF ledger of a client may be permitted.</a:t>
             </a:r>
           </a:p>
           <a:p>
@@ -13348,7 +14375,7 @@
               <a:defRPr sz="1100"/>
             </a:pPr>
             <a:r>
-              <a:t>4. Abbreviated Disclosures for Short-Format Messaging: Allowing abbreviated disclosures in short format messaging such as SMS, pop-ups, push notifications, etc., with a hyperlink to full details and disclaimers available on the official website of the regulated entity. This change recognizes the space/time constraints of these formats and aims to make disclosures more practical and user-friendly.</a:t>
+              <a:t>5. Funded stock as maintenance margin: If the broker has collected cash collateral from the client in form of margin for availing margin trading facility and transferred to the client's demat account for the purpose of MTF, without seeking specific obligation (pay-in) from the client, then the same can be considered as maintenance margin to the extent of securities received from the Clearing Corporation against such cash collateral given to CC.</a:t>
             </a:r>
           </a:p>
           <a:p>
@@ -13362,7 +14389,21 @@
               <a:defRPr sz="1100"/>
             </a:pPr>
             <a:r>
-              <a:t>The proposed changes aim to improve ease of doing business, consolidate existing advertisement codes, enhance investor protection, ensure regulatory consistency, promote accountability through post-issuance reporting, and rationalize compliance requirements. The final decision will be made after considering feedback from stakeholders.</a:t>
+              <a:t>6. Higher maintenance margin for cash being used as pay-in: In case the funded stock is considered towards maintenance margin to the extent of cash collateral provided by the client, the Trading Member shall ensure that the funded position may be only to the extent of stocks bought through stock brokers with funds. The applicable margin shall be VaR + 5 times of Extreme Loss Margin, irrespective of whether the funded stock is available in F&amp;O segment or not.</a:t>
+            </a:r>
+          </a:p>
+          <a:p>
+            <a:pPr>
+              <a:spcBef>
+                <a:spcPts val="400"/>
+              </a:spcBef>
+              <a:spcAft>
+                <a:spcPts val="600"/>
+              </a:spcAft>
+              <a:defRPr sz="1100"/>
+            </a:pPr>
+            <a:r>
+              <a:t>Public comments are invited on these proposals, and suggestions can be submitted through SEBI's web-based public comment system by July 09, 2026. The consultation paper also asks for additional safeguards/changes that may be considered in the MTF Framework.</a:t>
             </a:r>
           </a:p>
         </p:txBody>
@@ -13375,8 +14416,8 @@
         </p:nvSpPr>
         <p:spPr>
           <a:xfrm>
-            <a:off x="457200" y="6903720"/>
-            <a:ext cx="6583680" cy="2505456"/>
+            <a:off x="457200" y="6848856"/>
+            <a:ext cx="6583680" cy="2606040"/>
           </a:xfrm>
           <a:prstGeom prst="rect">
             <a:avLst/>
@@ -13401,7 +14442,7 @@
                 </a:solidFill>
                 <a:hlinkClick r:id="rId3"/>
               </a:rPr>
-              <a:t>Consultation Paper on Review of Margin Trading Facility (MTF) Framework</a:t>
+              <a:t>Consultation paper on review of provisions on disclosure of Executive Remuneration by Asset Management Companies (AMCs).</a:t>
             </a:r>
           </a:p>
           <a:p>
@@ -13415,21 +14456,21 @@
               <a:defRPr sz="1100"/>
             </a:pPr>
             <a:r>
-              <a:t>The document provides a proposal to review and modify the Margin Trading Facility (MTF) Framework in India, which is currently limited to Equity Shares and units of Equity ETFs that are classified as 'Group I security'. The changes aim to enhance the functionality, reduce the minimum net-worth threshold for eligibility, and introduce new disclosure requirements.</a:t>
+              <a:t>Title: Proposal for Consolidated Remuneration Disclosure in Mutual Funds</a:t>
             </a:r>
           </a:p>
           <a:p>
             <a:pPr>
               <a:spcBef>
-                <a:spcPts val="1200"/>
-              </a:spcBef>
-              <a:spcAft>
                 <a:spcPts val="400"/>
-              </a:spcAft>
-              <a:defRPr sz="1100" b="1"/>
-            </a:pPr>
-            <a:r>
-              <a:t>Here's a summary of the proposed changes:</a:t>
+              </a:spcBef>
+              <a:spcAft>
+                <a:spcPts val="600"/>
+              </a:spcAft>
+              <a:defRPr sz="1100"/>
+            </a:pPr>
+            <a:r>
+              <a:t>This text discusses a proposal to amend the disclosure of remuneration in mutual funds under the SEBI Master Circular for Mutual Funds dated March 20, 2026. The current practice involves disclosing individual employee remuneration on the website of Asset Management Companies (AMCs). However, an analysis suggests that this approach covers a small proportion of the overall employee base.</a:t>
             </a:r>
           </a:p>
           <a:p>
@@ -13443,21 +14484,7 @@
               <a:defRPr sz="1100"/>
             </a:pPr>
             <a:r>
-              <a:t>1. Increase in minimum net worth: Eligibility of Stock Brokers to offer MTF may be increased from Rs. 3.00 crore to Rs. 5 Crore.</a:t>
-            </a:r>
-          </a:p>
-          <a:p>
-            <a:pPr>
-              <a:spcBef>
-                <a:spcPts val="400"/>
-              </a:spcBef>
-              <a:spcAft>
-                <a:spcPts val="600"/>
-              </a:spcAft>
-              <a:defRPr sz="1100"/>
-            </a:pPr>
-            <a:r>
-              <a:t>2. Allowance for LLPs: Brokers in the form of Limited Liability Partnership (LLP) may also be allowed to offer MTF to their clients.</a:t>
+              <a:t>The proposal aims to replace individual employee remuneration with consolidated remuneration along with the total number of such employees. This change would provide a holistic and structured view of senior management compensation, enabling unitholders to assess the overall quantum of remuneration at the senior management level, while aligning the level of disclosure with considerations of materiality and proportionality.</a:t>
             </a:r>
           </a:p>
         </p:txBody>
@@ -13878,7 +14905,7 @@
                 <a:cs typeface="Montserrat Classic Bold"/>
                 <a:sym typeface="Montserrat Classic Bold"/>
               </a:rPr>
-              <a:t>Page 9 of 12</a:t>
+              <a:t>Page 9 of 13</a:t>
             </a:r>
           </a:p>
         </p:txBody>
@@ -14295,7 +15322,7 @@
         <p:spPr>
           <a:xfrm>
             <a:off x="457200" y="1828800"/>
-            <a:ext cx="6583680" cy="4005072"/>
+            <a:ext cx="6583680" cy="6355080"/>
           </a:xfrm>
           <a:prstGeom prst="rect">
             <a:avLst/>
@@ -14310,7 +15337,147 @@
           <a:p>
             <a:pPr>
               <a:spcBef>
+                <a:spcPts val="1200"/>
+              </a:spcBef>
+              <a:spcAft>
                 <a:spcPts val="400"/>
+              </a:spcAft>
+              <a:defRPr sz="1100" b="1"/>
+            </a:pPr>
+            <a:r>
+              <a:t>The new illustrative disclosure format includes:</a:t>
+            </a:r>
+          </a:p>
+          <a:p>
+            <a:pPr>
+              <a:spcBef>
+                <a:spcPts val="1200"/>
+              </a:spcBef>
+              <a:spcAft>
+                <a:spcPts val="400"/>
+              </a:spcAft>
+              <a:defRPr sz="1100" b="1"/>
+            </a:pPr>
+            <a:r>
+              <a:t>1. Annual Remuneration for the period…. for employees of….. (name of the AMC):</a:t>
+            </a:r>
+          </a:p>
+          <a:p>
+            <a:pPr>
+              <a:spcBef>
+                <a:spcPts val="0"/>
+              </a:spcBef>
+              <a:spcAft>
+                <a:spcPts val="200"/>
+              </a:spcAft>
+              <a:defRPr sz="1100"/>
+            </a:pPr>
+            <a:r>
+              <a:t>- Particulars</a:t>
+            </a:r>
+          </a:p>
+          <a:p>
+            <a:pPr>
+              <a:spcBef>
+                <a:spcPts val="0"/>
+              </a:spcBef>
+              <a:spcAft>
+                <a:spcPts val="200"/>
+              </a:spcAft>
+              <a:defRPr sz="1100"/>
+            </a:pPr>
+            <a:r>
+              <a:t>- Total number of employees</a:t>
+            </a:r>
+          </a:p>
+          <a:p>
+            <a:pPr>
+              <a:spcBef>
+                <a:spcPts val="0"/>
+              </a:spcBef>
+              <a:spcAft>
+                <a:spcPts val="200"/>
+              </a:spcAft>
+              <a:defRPr sz="1100"/>
+            </a:pPr>
+            <a:r>
+              <a:t>- Total remuneration (in INR crore)</a:t>
+            </a:r>
+          </a:p>
+          <a:p>
+            <a:pPr>
+              <a:spcBef>
+                <a:spcPts val="0"/>
+              </a:spcBef>
+              <a:spcAft>
+                <a:spcPts val="200"/>
+              </a:spcAft>
+              <a:defRPr sz="1100"/>
+            </a:pPr>
+            <a:r>
+              <a:t>- Chief Executive Officer (CEO), Chief Investment Officer (CIO), and Chief Operations Officer (COO) or their equivalent by whatever name called.</a:t>
+            </a:r>
+          </a:p>
+          <a:p>
+            <a:pPr>
+              <a:spcBef>
+                <a:spcPts val="1200"/>
+              </a:spcBef>
+              <a:spcAft>
+                <a:spcPts val="400"/>
+              </a:spcAft>
+              <a:defRPr sz="1100" b="1"/>
+            </a:pPr>
+            <a:r>
+              <a:t>2. Details of top ten employees in terms of remuneration for the period….:</a:t>
+            </a:r>
+          </a:p>
+          <a:p>
+            <a:pPr>
+              <a:spcBef>
+                <a:spcPts val="0"/>
+              </a:spcBef>
+              <a:spcAft>
+                <a:spcPts val="200"/>
+              </a:spcAft>
+              <a:defRPr sz="1100"/>
+            </a:pPr>
+            <a:r>
+              <a:t>- Particulars</a:t>
+            </a:r>
+          </a:p>
+          <a:p>
+            <a:pPr>
+              <a:spcBef>
+                <a:spcPts val="0"/>
+              </a:spcBef>
+              <a:spcAft>
+                <a:spcPts val="200"/>
+              </a:spcAft>
+              <a:defRPr sz="1100"/>
+            </a:pPr>
+            <a:r>
+              <a:t>- Total remuneration (in INR crore)</a:t>
+            </a:r>
+          </a:p>
+          <a:p>
+            <a:pPr>
+              <a:spcBef>
+                <a:spcPts val="0"/>
+              </a:spcBef>
+              <a:spcAft>
+                <a:spcPts val="200"/>
+              </a:spcAft>
+              <a:defRPr sz="1100"/>
+            </a:pPr>
+            <a:r>
+              <a:t>- Top ten employees in terms of remuneration drawn for that financial year</a:t>
+            </a:r>
+          </a:p>
+          <a:p>
+            <a:pPr>
+              <a:spcBef>
+                <a:spcPts val="400"/>
               </a:spcBef>
               <a:spcAft>
                 <a:spcPts val="600"/>
@@ -14318,12 +15485,68 @@
               <a:defRPr sz="1100"/>
             </a:pPr>
             <a:r>
-              <a:t>3. Disclosure requirements: Stock brokers are required to report MTF details on a gross exposure basis to Stock Exchanges on T+1 day, including the name of the client, category of holding, clients' Permanent Account Number (PAN), and the names of lenders and amounts borrowed.</a:t>
+              <a:t>3. Annual Remuneration for the period…. for all employees whose annual remuneration is INR 1.02 crores or more OR monthly remuneration is INR 8.5 lakhs if employed for part of the year:</a:t>
             </a:r>
           </a:p>
           <a:p>
             <a:pPr>
               <a:spcBef>
+                <a:spcPts val="0"/>
+              </a:spcBef>
+              <a:spcAft>
+                <a:spcPts val="200"/>
+              </a:spcAft>
+              <a:defRPr sz="1100"/>
+            </a:pPr>
+            <a:r>
+              <a:t>- Particulars</a:t>
+            </a:r>
+          </a:p>
+          <a:p>
+            <a:pPr>
+              <a:spcBef>
+                <a:spcPts val="0"/>
+              </a:spcBef>
+              <a:spcAft>
+                <a:spcPts val="200"/>
+              </a:spcAft>
+              <a:defRPr sz="1100"/>
+            </a:pPr>
+            <a:r>
+              <a:t>- Total number of employees</a:t>
+            </a:r>
+          </a:p>
+          <a:p>
+            <a:pPr>
+              <a:spcBef>
+                <a:spcPts val="0"/>
+              </a:spcBef>
+              <a:spcAft>
+                <a:spcPts val="200"/>
+              </a:spcAft>
+              <a:defRPr sz="1100"/>
+            </a:pPr>
+            <a:r>
+              <a:t>- Total remuneration (in INR crore)</a:t>
+            </a:r>
+          </a:p>
+          <a:p>
+            <a:pPr>
+              <a:spcBef>
+                <a:spcPts val="0"/>
+              </a:spcBef>
+              <a:spcAft>
+                <a:spcPts val="200"/>
+              </a:spcAft>
+              <a:defRPr sz="1100"/>
+            </a:pPr>
+            <a:r>
+              <a:t>- Employees whose annual remuneration was equal to or above INR 1.02 crore for the financial year or whose monthly remuneration in aggregate was not less than INR 8.5 lakhs per month, if the employee is employed for a part of that financial year.</a:t>
+            </a:r>
+          </a:p>
+          <a:p>
+            <a:pPr>
+              <a:spcBef>
                 <a:spcPts val="400"/>
               </a:spcBef>
               <a:spcAft>
@@ -14332,7 +15555,7 @@
               <a:defRPr sz="1100"/>
             </a:pPr>
             <a:r>
-              <a:t>4. Transfer of entries: Stock brokers should maintain separate ledgers for funds and securities of clients availing margin trading facility. Fungibility of unencumbered funds or securities between the normal ledger and the MTF ledger of a client may be permitted.</a:t>
+              <a:t>4. The ratio of CEO’s remuneration to median remuneration of AMC employees (in the current format followed by AMCs).</a:t>
             </a:r>
           </a:p>
           <a:p>
@@ -14346,158 +15569,77 @@
               <a:defRPr sz="1100"/>
             </a:pPr>
             <a:r>
-              <a:t>5. Funded stock as maintenance margin: If the broker has collected cash collateral from the client in form of margin for availing margin trading facility and transferred to the client's demat account for the purpose of MTF, without seeking specific obligation (pay-in) from the client, then the same can be considered as maintenance margin to the extent of securities received from the Clearing Corporation against such cash collateral given to CC.</a:t>
+              <a:t>5. MF’s total AAUM, debt AAUM and equity AAUM and rate of growth over last three years:</a:t>
             </a:r>
           </a:p>
           <a:p>
             <a:pPr>
               <a:spcBef>
-                <a:spcPts val="400"/>
-              </a:spcBef>
-              <a:spcAft>
-                <a:spcPts val="600"/>
+                <a:spcPts val="0"/>
+              </a:spcBef>
+              <a:spcAft>
+                <a:spcPts val="200"/>
               </a:spcAft>
               <a:defRPr sz="1100"/>
             </a:pPr>
             <a:r>
-              <a:t>6. Higher maintenance margin for cash being used as pay-in: In case the funded stock is considered towards maintenance margin to the extent of cash collateral provided by the client, the Trading Member shall ensure that the funded position may be only to the extent of stocks bought through stock brokers with funds. The applicable margin shall be VaR + 5 times of Extreme Loss Margin, irrespective of whether the funded stock is available in F&amp;O segment or not.</a:t>
+              <a:t>- Year</a:t>
             </a:r>
           </a:p>
           <a:p>
             <a:pPr>
               <a:spcBef>
-                <a:spcPts val="400"/>
-              </a:spcBef>
-              <a:spcAft>
-                <a:spcPts val="600"/>
+                <a:spcPts val="0"/>
+              </a:spcBef>
+              <a:spcAft>
+                <a:spcPts val="200"/>
               </a:spcAft>
               <a:defRPr sz="1100"/>
             </a:pPr>
             <a:r>
-              <a:t>Public comments are invited on these proposals, and suggestions can be submitted through SEBI's web-based public comment system by July 09, 2026. The consultation paper also asks for additional safeguards/changes that may be considered in the MTF Framework.</a:t>
-            </a:r>
-          </a:p>
-        </p:txBody>
-      </p:sp>
-      <p:sp>
-        <p:nvSpPr>
-          <p:cNvPr id="17" name="TextBox 16"/>
-          <p:cNvSpPr txBox="1"/>
-          <p:nvPr/>
-        </p:nvSpPr>
-        <p:spPr>
-          <a:xfrm>
-            <a:off x="457200" y="5971032"/>
-            <a:ext cx="6583680" cy="3602736"/>
-          </a:xfrm>
-          <a:prstGeom prst="rect">
-            <a:avLst/>
-          </a:prstGeom>
-          <a:noFill/>
-        </p:spPr>
-        <p:txBody>
-          <a:bodyPr wrap="square">
-            <a:spAutoFit/>
-          </a:bodyPr>
-          <a:lstStyle/>
+              <a:t>- Total AAUM</a:t>
+            </a:r>
+          </a:p>
           <a:p>
             <a:pPr>
-              <a:spcAft>
-                <a:spcPts val="600"/>
-              </a:spcAft>
-            </a:pPr>
-            <a:r>
-              <a:rPr b="1" sz="1200" u="sng">
-                <a:solidFill>
-                  <a:srgbClr val="0066CC"/>
-                </a:solidFill>
-                <a:hlinkClick r:id="rId4"/>
-              </a:rPr>
-              <a:t>Consultation paper on review of provisions on disclosure of Executive Remuneration by Asset Management Companies (AMCs).</a:t>
+              <a:spcBef>
+                <a:spcPts val="0"/>
+              </a:spcBef>
+              <a:spcAft>
+                <a:spcPts val="200"/>
+              </a:spcAft>
+              <a:defRPr sz="1100"/>
+            </a:pPr>
+            <a:r>
+              <a:t>- % of Debt AAUM</a:t>
             </a:r>
           </a:p>
           <a:p>
             <a:pPr>
               <a:spcBef>
-                <a:spcPts val="400"/>
-              </a:spcBef>
-              <a:spcAft>
-                <a:spcPts val="600"/>
+                <a:spcPts val="0"/>
+              </a:spcBef>
+              <a:spcAft>
+                <a:spcPts val="200"/>
               </a:spcAft>
               <a:defRPr sz="1100"/>
             </a:pPr>
             <a:r>
-              <a:t>Title: Proposal for Consolidated Remuneration Disclosure in Mutual Funds</a:t>
+              <a:t>- % of Equity AAUM</a:t>
             </a:r>
           </a:p>
           <a:p>
             <a:pPr>
               <a:spcBef>
-                <a:spcPts val="400"/>
-              </a:spcBef>
-              <a:spcAft>
-                <a:spcPts val="600"/>
+                <a:spcPts val="0"/>
+              </a:spcBef>
+              <a:spcAft>
+                <a:spcPts val="200"/>
               </a:spcAft>
               <a:defRPr sz="1100"/>
             </a:pPr>
             <a:r>
-              <a:t>This text discusses a proposal to amend the disclosure of remuneration in mutual funds under the SEBI Master Circular for Mutual Funds dated March 20, 2026. The current practice involves disclosing individual employee remuneration on the website of Asset Management Companies (AMCs). However, an analysis suggests that this approach covers a small proportion of the overall employee base.</a:t>
-            </a:r>
-          </a:p>
-          <a:p>
-            <a:pPr>
-              <a:spcBef>
-                <a:spcPts val="400"/>
-              </a:spcBef>
-              <a:spcAft>
-                <a:spcPts val="600"/>
-              </a:spcAft>
-              <a:defRPr sz="1100"/>
-            </a:pPr>
-            <a:r>
-              <a:t>The proposal aims to replace individual employee remuneration with consolidated remuneration along with the total number of such employees. This change would provide a holistic and structured view of senior management compensation, enabling unitholders to assess the overall quantum of remuneration at the senior management level, while aligning the level of disclosure with considerations of materiality and proportionality.</a:t>
-            </a:r>
-          </a:p>
-          <a:p>
-            <a:pPr>
-              <a:spcBef>
-                <a:spcPts val="1200"/>
-              </a:spcBef>
-              <a:spcAft>
-                <a:spcPts val="400"/>
-              </a:spcAft>
-              <a:defRPr sz="1100" b="1"/>
-            </a:pPr>
-            <a:r>
-              <a:t>The new illustrative disclosure format includes:</a:t>
-            </a:r>
-          </a:p>
-          <a:p>
-            <a:pPr>
-              <a:spcBef>
-                <a:spcPts val="1200"/>
-              </a:spcBef>
-              <a:spcAft>
-                <a:spcPts val="400"/>
-              </a:spcAft>
-              <a:defRPr sz="1100" b="1"/>
-            </a:pPr>
-            <a:r>
-              <a:t>1. Annual Remuneration for the period…. for employees of….. (name of the AMC):</a:t>
-            </a:r>
-          </a:p>
-          <a:p>
-            <a:pPr>
-              <a:spcBef>
-                <a:spcPts val="0"/>
-              </a:spcBef>
-              <a:spcAft>
-                <a:spcPts val="200"/>
-              </a:spcAft>
-              <a:defRPr sz="1100"/>
-            </a:pPr>
-            <a:r>
-              <a:t>- Particulars</a:t>
+              <a:t>- % of growth (INR in crore over the previous year)</a:t>
             </a:r>
           </a:p>
         </p:txBody>

</xml_diff>